<commit_message>
Forum 1 Theme B: two composite job postings and facilitator notes
</commit_message>
<xml_diff>
--- a/2026-27/S01/MLOps_S01_Foundations_Personas_Lifecycle.pptx
+++ b/2026-27/S01/MLOps_S01_Foundations_Personas_Lifecycle.pptx
@@ -1739,6 +1739,9 @@
 Steps: ingestion and versioning (get the data and record which version); validation (is it what we expect?); pre-processing (turn it into the shape the model needs, the same way every time); training; tuning (find the best settings); analysis (look at performance in depth, by segment); validation (is it better than what is in production, and safe?); deployment (put it where the business uses it); feedback (collect what happened and learn).
 Timing: minute 51–54.</a:t>
             </a:r>
+          </a:p>
+          <a:p>
+            <a:endParaRPr lang="en-US" dirty="0"/>
           </a:p>
         </p:txBody>
       </p:sp>
@@ -18686,6 +18689,1561 @@
   <p:clrMapOvr>
     <a:masterClrMapping/>
   </p:clrMapOvr>
+  <p:timing>
+    <p:tnLst>
+      <p:par>
+        <p:cTn id="1" dur="indefinite" restart="never" nodeType="tmRoot">
+          <p:childTnLst>
+            <p:seq concurrent="1" nextAc="seek">
+              <p:cTn id="2" dur="indefinite" nodeType="mainSeq">
+                <p:childTnLst>
+                  <p:par>
+                    <p:cTn id="3" fill="hold">
+                      <p:stCondLst>
+                        <p:cond delay="indefinite"/>
+                      </p:stCondLst>
+                      <p:childTnLst>
+                        <p:par>
+                          <p:cTn id="4" fill="hold">
+                            <p:stCondLst>
+                              <p:cond delay="0"/>
+                            </p:stCondLst>
+                            <p:childTnLst>
+                              <p:par>
+                                <p:cTn id="5" presetID="1" presetClass="entr" presetSubtype="0" fill="hold" grpId="0" nodeType="clickEffect">
+                                  <p:stCondLst>
+                                    <p:cond delay="0"/>
+                                  </p:stCondLst>
+                                  <p:childTnLst>
+                                    <p:set>
+                                      <p:cBhvr>
+                                        <p:cTn id="6" dur="1" fill="hold">
+                                          <p:stCondLst>
+                                            <p:cond delay="0"/>
+                                          </p:stCondLst>
+                                        </p:cTn>
+                                        <p:tgtEl>
+                                          <p:spTgt spid="7"/>
+                                        </p:tgtEl>
+                                        <p:attrNameLst>
+                                          <p:attrName>style.visibility</p:attrName>
+                                        </p:attrNameLst>
+                                      </p:cBhvr>
+                                      <p:to>
+                                        <p:strVal val="visible"/>
+                                      </p:to>
+                                    </p:set>
+                                  </p:childTnLst>
+                                </p:cTn>
+                              </p:par>
+                              <p:par>
+                                <p:cTn id="7" presetID="1" presetClass="entr" presetSubtype="0" fill="hold" grpId="0" nodeType="withEffect">
+                                  <p:stCondLst>
+                                    <p:cond delay="0"/>
+                                  </p:stCondLst>
+                                  <p:childTnLst>
+                                    <p:set>
+                                      <p:cBhvr>
+                                        <p:cTn id="8" dur="1" fill="hold">
+                                          <p:stCondLst>
+                                            <p:cond delay="0"/>
+                                          </p:stCondLst>
+                                        </p:cTn>
+                                        <p:tgtEl>
+                                          <p:spTgt spid="8"/>
+                                        </p:tgtEl>
+                                        <p:attrNameLst>
+                                          <p:attrName>style.visibility</p:attrName>
+                                        </p:attrNameLst>
+                                      </p:cBhvr>
+                                      <p:to>
+                                        <p:strVal val="visible"/>
+                                      </p:to>
+                                    </p:set>
+                                  </p:childTnLst>
+                                </p:cTn>
+                              </p:par>
+                              <p:par>
+                                <p:cTn id="9" presetID="1" presetClass="entr" presetSubtype="0" fill="hold" grpId="0" nodeType="withEffect">
+                                  <p:stCondLst>
+                                    <p:cond delay="0"/>
+                                  </p:stCondLst>
+                                  <p:childTnLst>
+                                    <p:set>
+                                      <p:cBhvr>
+                                        <p:cTn id="10" dur="1" fill="hold">
+                                          <p:stCondLst>
+                                            <p:cond delay="0"/>
+                                          </p:stCondLst>
+                                        </p:cTn>
+                                        <p:tgtEl>
+                                          <p:spTgt spid="9"/>
+                                        </p:tgtEl>
+                                        <p:attrNameLst>
+                                          <p:attrName>style.visibility</p:attrName>
+                                        </p:attrNameLst>
+                                      </p:cBhvr>
+                                      <p:to>
+                                        <p:strVal val="visible"/>
+                                      </p:to>
+                                    </p:set>
+                                  </p:childTnLst>
+                                </p:cTn>
+                              </p:par>
+                              <p:par>
+                                <p:cTn id="11" presetID="1" presetClass="entr" presetSubtype="0" fill="hold" grpId="0" nodeType="withEffect">
+                                  <p:stCondLst>
+                                    <p:cond delay="0"/>
+                                  </p:stCondLst>
+                                  <p:childTnLst>
+                                    <p:set>
+                                      <p:cBhvr>
+                                        <p:cTn id="12" dur="1" fill="hold">
+                                          <p:stCondLst>
+                                            <p:cond delay="0"/>
+                                          </p:stCondLst>
+                                        </p:cTn>
+                                        <p:tgtEl>
+                                          <p:spTgt spid="10"/>
+                                        </p:tgtEl>
+                                        <p:attrNameLst>
+                                          <p:attrName>style.visibility</p:attrName>
+                                        </p:attrNameLst>
+                                      </p:cBhvr>
+                                      <p:to>
+                                        <p:strVal val="visible"/>
+                                      </p:to>
+                                    </p:set>
+                                  </p:childTnLst>
+                                </p:cTn>
+                              </p:par>
+                              <p:par>
+                                <p:cTn id="13" presetID="1" presetClass="entr" presetSubtype="0" fill="hold" grpId="0" nodeType="withEffect">
+                                  <p:stCondLst>
+                                    <p:cond delay="0"/>
+                                  </p:stCondLst>
+                                  <p:childTnLst>
+                                    <p:set>
+                                      <p:cBhvr>
+                                        <p:cTn id="14" dur="1" fill="hold">
+                                          <p:stCondLst>
+                                            <p:cond delay="0"/>
+                                          </p:stCondLst>
+                                        </p:cTn>
+                                        <p:tgtEl>
+                                          <p:spTgt spid="11"/>
+                                        </p:tgtEl>
+                                        <p:attrNameLst>
+                                          <p:attrName>style.visibility</p:attrName>
+                                        </p:attrNameLst>
+                                      </p:cBhvr>
+                                      <p:to>
+                                        <p:strVal val="visible"/>
+                                      </p:to>
+                                    </p:set>
+                                  </p:childTnLst>
+                                </p:cTn>
+                              </p:par>
+                            </p:childTnLst>
+                          </p:cTn>
+                        </p:par>
+                      </p:childTnLst>
+                    </p:cTn>
+                  </p:par>
+                  <p:par>
+                    <p:cTn id="15" fill="hold">
+                      <p:stCondLst>
+                        <p:cond delay="indefinite"/>
+                      </p:stCondLst>
+                      <p:childTnLst>
+                        <p:par>
+                          <p:cTn id="16" fill="hold">
+                            <p:stCondLst>
+                              <p:cond delay="0"/>
+                            </p:stCondLst>
+                            <p:childTnLst>
+                              <p:par>
+                                <p:cTn id="17" presetID="1" presetClass="entr" presetSubtype="0" fill="hold" grpId="0" nodeType="clickEffect">
+                                  <p:stCondLst>
+                                    <p:cond delay="0"/>
+                                  </p:stCondLst>
+                                  <p:childTnLst>
+                                    <p:set>
+                                      <p:cBhvr>
+                                        <p:cTn id="18" dur="1" fill="hold">
+                                          <p:stCondLst>
+                                            <p:cond delay="0"/>
+                                          </p:stCondLst>
+                                        </p:cTn>
+                                        <p:tgtEl>
+                                          <p:spTgt spid="12"/>
+                                        </p:tgtEl>
+                                        <p:attrNameLst>
+                                          <p:attrName>style.visibility</p:attrName>
+                                        </p:attrNameLst>
+                                      </p:cBhvr>
+                                      <p:to>
+                                        <p:strVal val="visible"/>
+                                      </p:to>
+                                    </p:set>
+                                  </p:childTnLst>
+                                </p:cTn>
+                              </p:par>
+                              <p:par>
+                                <p:cTn id="19" presetID="1" presetClass="entr" presetSubtype="0" fill="hold" grpId="0" nodeType="withEffect">
+                                  <p:stCondLst>
+                                    <p:cond delay="0"/>
+                                  </p:stCondLst>
+                                  <p:childTnLst>
+                                    <p:set>
+                                      <p:cBhvr>
+                                        <p:cTn id="20" dur="1" fill="hold">
+                                          <p:stCondLst>
+                                            <p:cond delay="0"/>
+                                          </p:stCondLst>
+                                        </p:cTn>
+                                        <p:tgtEl>
+                                          <p:spTgt spid="13"/>
+                                        </p:tgtEl>
+                                        <p:attrNameLst>
+                                          <p:attrName>style.visibility</p:attrName>
+                                        </p:attrNameLst>
+                                      </p:cBhvr>
+                                      <p:to>
+                                        <p:strVal val="visible"/>
+                                      </p:to>
+                                    </p:set>
+                                  </p:childTnLst>
+                                </p:cTn>
+                              </p:par>
+                              <p:par>
+                                <p:cTn id="21" presetID="1" presetClass="entr" presetSubtype="0" fill="hold" grpId="0" nodeType="withEffect">
+                                  <p:stCondLst>
+                                    <p:cond delay="0"/>
+                                  </p:stCondLst>
+                                  <p:childTnLst>
+                                    <p:set>
+                                      <p:cBhvr>
+                                        <p:cTn id="22" dur="1" fill="hold">
+                                          <p:stCondLst>
+                                            <p:cond delay="0"/>
+                                          </p:stCondLst>
+                                        </p:cTn>
+                                        <p:tgtEl>
+                                          <p:spTgt spid="14"/>
+                                        </p:tgtEl>
+                                        <p:attrNameLst>
+                                          <p:attrName>style.visibility</p:attrName>
+                                        </p:attrNameLst>
+                                      </p:cBhvr>
+                                      <p:to>
+                                        <p:strVal val="visible"/>
+                                      </p:to>
+                                    </p:set>
+                                  </p:childTnLst>
+                                </p:cTn>
+                              </p:par>
+                              <p:par>
+                                <p:cTn id="23" presetID="1" presetClass="entr" presetSubtype="0" fill="hold" grpId="0" nodeType="withEffect">
+                                  <p:stCondLst>
+                                    <p:cond delay="0"/>
+                                  </p:stCondLst>
+                                  <p:childTnLst>
+                                    <p:set>
+                                      <p:cBhvr>
+                                        <p:cTn id="24" dur="1" fill="hold">
+                                          <p:stCondLst>
+                                            <p:cond delay="0"/>
+                                          </p:stCondLst>
+                                        </p:cTn>
+                                        <p:tgtEl>
+                                          <p:spTgt spid="15"/>
+                                        </p:tgtEl>
+                                        <p:attrNameLst>
+                                          <p:attrName>style.visibility</p:attrName>
+                                        </p:attrNameLst>
+                                      </p:cBhvr>
+                                      <p:to>
+                                        <p:strVal val="visible"/>
+                                      </p:to>
+                                    </p:set>
+                                  </p:childTnLst>
+                                </p:cTn>
+                              </p:par>
+                              <p:par>
+                                <p:cTn id="25" presetID="1" presetClass="entr" presetSubtype="0" fill="hold" grpId="0" nodeType="withEffect">
+                                  <p:stCondLst>
+                                    <p:cond delay="0"/>
+                                  </p:stCondLst>
+                                  <p:childTnLst>
+                                    <p:set>
+                                      <p:cBhvr>
+                                        <p:cTn id="26" dur="1" fill="hold">
+                                          <p:stCondLst>
+                                            <p:cond delay="0"/>
+                                          </p:stCondLst>
+                                        </p:cTn>
+                                        <p:tgtEl>
+                                          <p:spTgt spid="16"/>
+                                        </p:tgtEl>
+                                        <p:attrNameLst>
+                                          <p:attrName>style.visibility</p:attrName>
+                                        </p:attrNameLst>
+                                      </p:cBhvr>
+                                      <p:to>
+                                        <p:strVal val="visible"/>
+                                      </p:to>
+                                    </p:set>
+                                  </p:childTnLst>
+                                </p:cTn>
+                              </p:par>
+                            </p:childTnLst>
+                          </p:cTn>
+                        </p:par>
+                      </p:childTnLst>
+                    </p:cTn>
+                  </p:par>
+                  <p:par>
+                    <p:cTn id="27" fill="hold">
+                      <p:stCondLst>
+                        <p:cond delay="indefinite"/>
+                      </p:stCondLst>
+                      <p:childTnLst>
+                        <p:par>
+                          <p:cTn id="28" fill="hold">
+                            <p:stCondLst>
+                              <p:cond delay="0"/>
+                            </p:stCondLst>
+                            <p:childTnLst>
+                              <p:par>
+                                <p:cTn id="29" presetID="1" presetClass="entr" presetSubtype="0" fill="hold" grpId="0" nodeType="clickEffect">
+                                  <p:stCondLst>
+                                    <p:cond delay="0"/>
+                                  </p:stCondLst>
+                                  <p:childTnLst>
+                                    <p:set>
+                                      <p:cBhvr>
+                                        <p:cTn id="30" dur="1" fill="hold">
+                                          <p:stCondLst>
+                                            <p:cond delay="0"/>
+                                          </p:stCondLst>
+                                        </p:cTn>
+                                        <p:tgtEl>
+                                          <p:spTgt spid="17"/>
+                                        </p:tgtEl>
+                                        <p:attrNameLst>
+                                          <p:attrName>style.visibility</p:attrName>
+                                        </p:attrNameLst>
+                                      </p:cBhvr>
+                                      <p:to>
+                                        <p:strVal val="visible"/>
+                                      </p:to>
+                                    </p:set>
+                                  </p:childTnLst>
+                                </p:cTn>
+                              </p:par>
+                              <p:par>
+                                <p:cTn id="31" presetID="1" presetClass="entr" presetSubtype="0" fill="hold" grpId="0" nodeType="withEffect">
+                                  <p:stCondLst>
+                                    <p:cond delay="0"/>
+                                  </p:stCondLst>
+                                  <p:childTnLst>
+                                    <p:set>
+                                      <p:cBhvr>
+                                        <p:cTn id="32" dur="1" fill="hold">
+                                          <p:stCondLst>
+                                            <p:cond delay="0"/>
+                                          </p:stCondLst>
+                                        </p:cTn>
+                                        <p:tgtEl>
+                                          <p:spTgt spid="18"/>
+                                        </p:tgtEl>
+                                        <p:attrNameLst>
+                                          <p:attrName>style.visibility</p:attrName>
+                                        </p:attrNameLst>
+                                      </p:cBhvr>
+                                      <p:to>
+                                        <p:strVal val="visible"/>
+                                      </p:to>
+                                    </p:set>
+                                  </p:childTnLst>
+                                </p:cTn>
+                              </p:par>
+                              <p:par>
+                                <p:cTn id="33" presetID="1" presetClass="entr" presetSubtype="0" fill="hold" grpId="0" nodeType="withEffect">
+                                  <p:stCondLst>
+                                    <p:cond delay="0"/>
+                                  </p:stCondLst>
+                                  <p:childTnLst>
+                                    <p:set>
+                                      <p:cBhvr>
+                                        <p:cTn id="34" dur="1" fill="hold">
+                                          <p:stCondLst>
+                                            <p:cond delay="0"/>
+                                          </p:stCondLst>
+                                        </p:cTn>
+                                        <p:tgtEl>
+                                          <p:spTgt spid="19"/>
+                                        </p:tgtEl>
+                                        <p:attrNameLst>
+                                          <p:attrName>style.visibility</p:attrName>
+                                        </p:attrNameLst>
+                                      </p:cBhvr>
+                                      <p:to>
+                                        <p:strVal val="visible"/>
+                                      </p:to>
+                                    </p:set>
+                                  </p:childTnLst>
+                                </p:cTn>
+                              </p:par>
+                              <p:par>
+                                <p:cTn id="35" presetID="1" presetClass="entr" presetSubtype="0" fill="hold" grpId="0" nodeType="withEffect">
+                                  <p:stCondLst>
+                                    <p:cond delay="0"/>
+                                  </p:stCondLst>
+                                  <p:childTnLst>
+                                    <p:set>
+                                      <p:cBhvr>
+                                        <p:cTn id="36" dur="1" fill="hold">
+                                          <p:stCondLst>
+                                            <p:cond delay="0"/>
+                                          </p:stCondLst>
+                                        </p:cTn>
+                                        <p:tgtEl>
+                                          <p:spTgt spid="20"/>
+                                        </p:tgtEl>
+                                        <p:attrNameLst>
+                                          <p:attrName>style.visibility</p:attrName>
+                                        </p:attrNameLst>
+                                      </p:cBhvr>
+                                      <p:to>
+                                        <p:strVal val="visible"/>
+                                      </p:to>
+                                    </p:set>
+                                  </p:childTnLst>
+                                </p:cTn>
+                              </p:par>
+                              <p:par>
+                                <p:cTn id="37" presetID="1" presetClass="entr" presetSubtype="0" fill="hold" grpId="0" nodeType="withEffect">
+                                  <p:stCondLst>
+                                    <p:cond delay="0"/>
+                                  </p:stCondLst>
+                                  <p:childTnLst>
+                                    <p:set>
+                                      <p:cBhvr>
+                                        <p:cTn id="38" dur="1" fill="hold">
+                                          <p:stCondLst>
+                                            <p:cond delay="0"/>
+                                          </p:stCondLst>
+                                        </p:cTn>
+                                        <p:tgtEl>
+                                          <p:spTgt spid="21"/>
+                                        </p:tgtEl>
+                                        <p:attrNameLst>
+                                          <p:attrName>style.visibility</p:attrName>
+                                        </p:attrNameLst>
+                                      </p:cBhvr>
+                                      <p:to>
+                                        <p:strVal val="visible"/>
+                                      </p:to>
+                                    </p:set>
+                                  </p:childTnLst>
+                                </p:cTn>
+                              </p:par>
+                            </p:childTnLst>
+                          </p:cTn>
+                        </p:par>
+                      </p:childTnLst>
+                    </p:cTn>
+                  </p:par>
+                  <p:par>
+                    <p:cTn id="39" fill="hold">
+                      <p:stCondLst>
+                        <p:cond delay="indefinite"/>
+                      </p:stCondLst>
+                      <p:childTnLst>
+                        <p:par>
+                          <p:cTn id="40" fill="hold">
+                            <p:stCondLst>
+                              <p:cond delay="0"/>
+                            </p:stCondLst>
+                            <p:childTnLst>
+                              <p:par>
+                                <p:cTn id="41" presetID="1" presetClass="entr" presetSubtype="0" fill="hold" grpId="0" nodeType="clickEffect">
+                                  <p:stCondLst>
+                                    <p:cond delay="0"/>
+                                  </p:stCondLst>
+                                  <p:childTnLst>
+                                    <p:set>
+                                      <p:cBhvr>
+                                        <p:cTn id="42" dur="1" fill="hold">
+                                          <p:stCondLst>
+                                            <p:cond delay="0"/>
+                                          </p:stCondLst>
+                                        </p:cTn>
+                                        <p:tgtEl>
+                                          <p:spTgt spid="22"/>
+                                        </p:tgtEl>
+                                        <p:attrNameLst>
+                                          <p:attrName>style.visibility</p:attrName>
+                                        </p:attrNameLst>
+                                      </p:cBhvr>
+                                      <p:to>
+                                        <p:strVal val="visible"/>
+                                      </p:to>
+                                    </p:set>
+                                  </p:childTnLst>
+                                </p:cTn>
+                              </p:par>
+                              <p:par>
+                                <p:cTn id="43" presetID="1" presetClass="entr" presetSubtype="0" fill="hold" grpId="0" nodeType="withEffect">
+                                  <p:stCondLst>
+                                    <p:cond delay="0"/>
+                                  </p:stCondLst>
+                                  <p:childTnLst>
+                                    <p:set>
+                                      <p:cBhvr>
+                                        <p:cTn id="44" dur="1" fill="hold">
+                                          <p:stCondLst>
+                                            <p:cond delay="0"/>
+                                          </p:stCondLst>
+                                        </p:cTn>
+                                        <p:tgtEl>
+                                          <p:spTgt spid="23"/>
+                                        </p:tgtEl>
+                                        <p:attrNameLst>
+                                          <p:attrName>style.visibility</p:attrName>
+                                        </p:attrNameLst>
+                                      </p:cBhvr>
+                                      <p:to>
+                                        <p:strVal val="visible"/>
+                                      </p:to>
+                                    </p:set>
+                                  </p:childTnLst>
+                                </p:cTn>
+                              </p:par>
+                              <p:par>
+                                <p:cTn id="45" presetID="1" presetClass="entr" presetSubtype="0" fill="hold" grpId="0" nodeType="withEffect">
+                                  <p:stCondLst>
+                                    <p:cond delay="0"/>
+                                  </p:stCondLst>
+                                  <p:childTnLst>
+                                    <p:set>
+                                      <p:cBhvr>
+                                        <p:cTn id="46" dur="1" fill="hold">
+                                          <p:stCondLst>
+                                            <p:cond delay="0"/>
+                                          </p:stCondLst>
+                                        </p:cTn>
+                                        <p:tgtEl>
+                                          <p:spTgt spid="24"/>
+                                        </p:tgtEl>
+                                        <p:attrNameLst>
+                                          <p:attrName>style.visibility</p:attrName>
+                                        </p:attrNameLst>
+                                      </p:cBhvr>
+                                      <p:to>
+                                        <p:strVal val="visible"/>
+                                      </p:to>
+                                    </p:set>
+                                  </p:childTnLst>
+                                </p:cTn>
+                              </p:par>
+                              <p:par>
+                                <p:cTn id="47" presetID="1" presetClass="entr" presetSubtype="0" fill="hold" grpId="0" nodeType="withEffect">
+                                  <p:stCondLst>
+                                    <p:cond delay="0"/>
+                                  </p:stCondLst>
+                                  <p:childTnLst>
+                                    <p:set>
+                                      <p:cBhvr>
+                                        <p:cTn id="48" dur="1" fill="hold">
+                                          <p:stCondLst>
+                                            <p:cond delay="0"/>
+                                          </p:stCondLst>
+                                        </p:cTn>
+                                        <p:tgtEl>
+                                          <p:spTgt spid="25"/>
+                                        </p:tgtEl>
+                                        <p:attrNameLst>
+                                          <p:attrName>style.visibility</p:attrName>
+                                        </p:attrNameLst>
+                                      </p:cBhvr>
+                                      <p:to>
+                                        <p:strVal val="visible"/>
+                                      </p:to>
+                                    </p:set>
+                                  </p:childTnLst>
+                                </p:cTn>
+                              </p:par>
+                              <p:par>
+                                <p:cTn id="49" presetID="1" presetClass="entr" presetSubtype="0" fill="hold" grpId="0" nodeType="withEffect">
+                                  <p:stCondLst>
+                                    <p:cond delay="0"/>
+                                  </p:stCondLst>
+                                  <p:childTnLst>
+                                    <p:set>
+                                      <p:cBhvr>
+                                        <p:cTn id="50" dur="1" fill="hold">
+                                          <p:stCondLst>
+                                            <p:cond delay="0"/>
+                                          </p:stCondLst>
+                                        </p:cTn>
+                                        <p:tgtEl>
+                                          <p:spTgt spid="26"/>
+                                        </p:tgtEl>
+                                        <p:attrNameLst>
+                                          <p:attrName>style.visibility</p:attrName>
+                                        </p:attrNameLst>
+                                      </p:cBhvr>
+                                      <p:to>
+                                        <p:strVal val="visible"/>
+                                      </p:to>
+                                    </p:set>
+                                  </p:childTnLst>
+                                </p:cTn>
+                              </p:par>
+                            </p:childTnLst>
+                          </p:cTn>
+                        </p:par>
+                      </p:childTnLst>
+                    </p:cTn>
+                  </p:par>
+                  <p:par>
+                    <p:cTn id="51" fill="hold">
+                      <p:stCondLst>
+                        <p:cond delay="indefinite"/>
+                      </p:stCondLst>
+                      <p:childTnLst>
+                        <p:par>
+                          <p:cTn id="52" fill="hold">
+                            <p:stCondLst>
+                              <p:cond delay="0"/>
+                            </p:stCondLst>
+                            <p:childTnLst>
+                              <p:par>
+                                <p:cTn id="53" presetID="1" presetClass="entr" presetSubtype="0" fill="hold" grpId="0" nodeType="clickEffect">
+                                  <p:stCondLst>
+                                    <p:cond delay="0"/>
+                                  </p:stCondLst>
+                                  <p:childTnLst>
+                                    <p:set>
+                                      <p:cBhvr>
+                                        <p:cTn id="54" dur="1" fill="hold">
+                                          <p:stCondLst>
+                                            <p:cond delay="0"/>
+                                          </p:stCondLst>
+                                        </p:cTn>
+                                        <p:tgtEl>
+                                          <p:spTgt spid="27"/>
+                                        </p:tgtEl>
+                                        <p:attrNameLst>
+                                          <p:attrName>style.visibility</p:attrName>
+                                        </p:attrNameLst>
+                                      </p:cBhvr>
+                                      <p:to>
+                                        <p:strVal val="visible"/>
+                                      </p:to>
+                                    </p:set>
+                                  </p:childTnLst>
+                                </p:cTn>
+                              </p:par>
+                              <p:par>
+                                <p:cTn id="55" presetID="1" presetClass="entr" presetSubtype="0" fill="hold" grpId="0" nodeType="withEffect">
+                                  <p:stCondLst>
+                                    <p:cond delay="0"/>
+                                  </p:stCondLst>
+                                  <p:childTnLst>
+                                    <p:set>
+                                      <p:cBhvr>
+                                        <p:cTn id="56" dur="1" fill="hold">
+                                          <p:stCondLst>
+                                            <p:cond delay="0"/>
+                                          </p:stCondLst>
+                                        </p:cTn>
+                                        <p:tgtEl>
+                                          <p:spTgt spid="28"/>
+                                        </p:tgtEl>
+                                        <p:attrNameLst>
+                                          <p:attrName>style.visibility</p:attrName>
+                                        </p:attrNameLst>
+                                      </p:cBhvr>
+                                      <p:to>
+                                        <p:strVal val="visible"/>
+                                      </p:to>
+                                    </p:set>
+                                  </p:childTnLst>
+                                </p:cTn>
+                              </p:par>
+                              <p:par>
+                                <p:cTn id="57" presetID="1" presetClass="entr" presetSubtype="0" fill="hold" grpId="0" nodeType="withEffect">
+                                  <p:stCondLst>
+                                    <p:cond delay="0"/>
+                                  </p:stCondLst>
+                                  <p:childTnLst>
+                                    <p:set>
+                                      <p:cBhvr>
+                                        <p:cTn id="58" dur="1" fill="hold">
+                                          <p:stCondLst>
+                                            <p:cond delay="0"/>
+                                          </p:stCondLst>
+                                        </p:cTn>
+                                        <p:tgtEl>
+                                          <p:spTgt spid="29"/>
+                                        </p:tgtEl>
+                                        <p:attrNameLst>
+                                          <p:attrName>style.visibility</p:attrName>
+                                        </p:attrNameLst>
+                                      </p:cBhvr>
+                                      <p:to>
+                                        <p:strVal val="visible"/>
+                                      </p:to>
+                                    </p:set>
+                                  </p:childTnLst>
+                                </p:cTn>
+                              </p:par>
+                              <p:par>
+                                <p:cTn id="59" presetID="1" presetClass="entr" presetSubtype="0" fill="hold" grpId="0" nodeType="withEffect">
+                                  <p:stCondLst>
+                                    <p:cond delay="0"/>
+                                  </p:stCondLst>
+                                  <p:childTnLst>
+                                    <p:set>
+                                      <p:cBhvr>
+                                        <p:cTn id="60" dur="1" fill="hold">
+                                          <p:stCondLst>
+                                            <p:cond delay="0"/>
+                                          </p:stCondLst>
+                                        </p:cTn>
+                                        <p:tgtEl>
+                                          <p:spTgt spid="30"/>
+                                        </p:tgtEl>
+                                        <p:attrNameLst>
+                                          <p:attrName>style.visibility</p:attrName>
+                                        </p:attrNameLst>
+                                      </p:cBhvr>
+                                      <p:to>
+                                        <p:strVal val="visible"/>
+                                      </p:to>
+                                    </p:set>
+                                  </p:childTnLst>
+                                </p:cTn>
+                              </p:par>
+                              <p:par>
+                                <p:cTn id="61" presetID="1" presetClass="entr" presetSubtype="0" fill="hold" grpId="0" nodeType="withEffect">
+                                  <p:stCondLst>
+                                    <p:cond delay="0"/>
+                                  </p:stCondLst>
+                                  <p:childTnLst>
+                                    <p:set>
+                                      <p:cBhvr>
+                                        <p:cTn id="62" dur="1" fill="hold">
+                                          <p:stCondLst>
+                                            <p:cond delay="0"/>
+                                          </p:stCondLst>
+                                        </p:cTn>
+                                        <p:tgtEl>
+                                          <p:spTgt spid="31"/>
+                                        </p:tgtEl>
+                                        <p:attrNameLst>
+                                          <p:attrName>style.visibility</p:attrName>
+                                        </p:attrNameLst>
+                                      </p:cBhvr>
+                                      <p:to>
+                                        <p:strVal val="visible"/>
+                                      </p:to>
+                                    </p:set>
+                                  </p:childTnLst>
+                                </p:cTn>
+                              </p:par>
+                              <p:par>
+                                <p:cTn id="63" presetID="1" presetClass="entr" presetSubtype="0" fill="hold" nodeType="withEffect">
+                                  <p:stCondLst>
+                                    <p:cond delay="0"/>
+                                  </p:stCondLst>
+                                  <p:childTnLst>
+                                    <p:set>
+                                      <p:cBhvr>
+                                        <p:cTn id="64" dur="1" fill="hold">
+                                          <p:stCondLst>
+                                            <p:cond delay="0"/>
+                                          </p:stCondLst>
+                                        </p:cTn>
+                                        <p:tgtEl>
+                                          <p:spTgt spid="55"/>
+                                        </p:tgtEl>
+                                        <p:attrNameLst>
+                                          <p:attrName>style.visibility</p:attrName>
+                                        </p:attrNameLst>
+                                      </p:cBhvr>
+                                      <p:to>
+                                        <p:strVal val="visible"/>
+                                      </p:to>
+                                    </p:set>
+                                  </p:childTnLst>
+                                </p:cTn>
+                              </p:par>
+                            </p:childTnLst>
+                          </p:cTn>
+                        </p:par>
+                      </p:childTnLst>
+                    </p:cTn>
+                  </p:par>
+                  <p:par>
+                    <p:cTn id="65" fill="hold">
+                      <p:stCondLst>
+                        <p:cond delay="indefinite"/>
+                      </p:stCondLst>
+                      <p:childTnLst>
+                        <p:par>
+                          <p:cTn id="66" fill="hold">
+                            <p:stCondLst>
+                              <p:cond delay="0"/>
+                            </p:stCondLst>
+                            <p:childTnLst>
+                              <p:par>
+                                <p:cTn id="67" presetID="1" presetClass="entr" presetSubtype="0" fill="hold" grpId="0" nodeType="clickEffect">
+                                  <p:stCondLst>
+                                    <p:cond delay="0"/>
+                                  </p:stCondLst>
+                                  <p:childTnLst>
+                                    <p:set>
+                                      <p:cBhvr>
+                                        <p:cTn id="68" dur="1" fill="hold">
+                                          <p:stCondLst>
+                                            <p:cond delay="0"/>
+                                          </p:stCondLst>
+                                        </p:cTn>
+                                        <p:tgtEl>
+                                          <p:spTgt spid="32"/>
+                                        </p:tgtEl>
+                                        <p:attrNameLst>
+                                          <p:attrName>style.visibility</p:attrName>
+                                        </p:attrNameLst>
+                                      </p:cBhvr>
+                                      <p:to>
+                                        <p:strVal val="visible"/>
+                                      </p:to>
+                                    </p:set>
+                                  </p:childTnLst>
+                                </p:cTn>
+                              </p:par>
+                              <p:par>
+                                <p:cTn id="69" presetID="1" presetClass="entr" presetSubtype="0" fill="hold" grpId="0" nodeType="withEffect">
+                                  <p:stCondLst>
+                                    <p:cond delay="0"/>
+                                  </p:stCondLst>
+                                  <p:childTnLst>
+                                    <p:set>
+                                      <p:cBhvr>
+                                        <p:cTn id="70" dur="1" fill="hold">
+                                          <p:stCondLst>
+                                            <p:cond delay="0"/>
+                                          </p:stCondLst>
+                                        </p:cTn>
+                                        <p:tgtEl>
+                                          <p:spTgt spid="33"/>
+                                        </p:tgtEl>
+                                        <p:attrNameLst>
+                                          <p:attrName>style.visibility</p:attrName>
+                                        </p:attrNameLst>
+                                      </p:cBhvr>
+                                      <p:to>
+                                        <p:strVal val="visible"/>
+                                      </p:to>
+                                    </p:set>
+                                  </p:childTnLst>
+                                </p:cTn>
+                              </p:par>
+                              <p:par>
+                                <p:cTn id="71" presetID="1" presetClass="entr" presetSubtype="0" fill="hold" grpId="0" nodeType="withEffect">
+                                  <p:stCondLst>
+                                    <p:cond delay="0"/>
+                                  </p:stCondLst>
+                                  <p:childTnLst>
+                                    <p:set>
+                                      <p:cBhvr>
+                                        <p:cTn id="72" dur="1" fill="hold">
+                                          <p:stCondLst>
+                                            <p:cond delay="0"/>
+                                          </p:stCondLst>
+                                        </p:cTn>
+                                        <p:tgtEl>
+                                          <p:spTgt spid="34"/>
+                                        </p:tgtEl>
+                                        <p:attrNameLst>
+                                          <p:attrName>style.visibility</p:attrName>
+                                        </p:attrNameLst>
+                                      </p:cBhvr>
+                                      <p:to>
+                                        <p:strVal val="visible"/>
+                                      </p:to>
+                                    </p:set>
+                                  </p:childTnLst>
+                                </p:cTn>
+                              </p:par>
+                              <p:par>
+                                <p:cTn id="73" presetID="1" presetClass="entr" presetSubtype="0" fill="hold" grpId="0" nodeType="withEffect">
+                                  <p:stCondLst>
+                                    <p:cond delay="0"/>
+                                  </p:stCondLst>
+                                  <p:childTnLst>
+                                    <p:set>
+                                      <p:cBhvr>
+                                        <p:cTn id="74" dur="1" fill="hold">
+                                          <p:stCondLst>
+                                            <p:cond delay="0"/>
+                                          </p:stCondLst>
+                                        </p:cTn>
+                                        <p:tgtEl>
+                                          <p:spTgt spid="35"/>
+                                        </p:tgtEl>
+                                        <p:attrNameLst>
+                                          <p:attrName>style.visibility</p:attrName>
+                                        </p:attrNameLst>
+                                      </p:cBhvr>
+                                      <p:to>
+                                        <p:strVal val="visible"/>
+                                      </p:to>
+                                    </p:set>
+                                  </p:childTnLst>
+                                </p:cTn>
+                              </p:par>
+                              <p:par>
+                                <p:cTn id="75" presetID="1" presetClass="entr" presetSubtype="0" fill="hold" grpId="0" nodeType="withEffect">
+                                  <p:stCondLst>
+                                    <p:cond delay="0"/>
+                                  </p:stCondLst>
+                                  <p:childTnLst>
+                                    <p:set>
+                                      <p:cBhvr>
+                                        <p:cTn id="76" dur="1" fill="hold">
+                                          <p:stCondLst>
+                                            <p:cond delay="0"/>
+                                          </p:stCondLst>
+                                        </p:cTn>
+                                        <p:tgtEl>
+                                          <p:spTgt spid="36"/>
+                                        </p:tgtEl>
+                                        <p:attrNameLst>
+                                          <p:attrName>style.visibility</p:attrName>
+                                        </p:attrNameLst>
+                                      </p:cBhvr>
+                                      <p:to>
+                                        <p:strVal val="visible"/>
+                                      </p:to>
+                                    </p:set>
+                                  </p:childTnLst>
+                                </p:cTn>
+                              </p:par>
+                            </p:childTnLst>
+                          </p:cTn>
+                        </p:par>
+                      </p:childTnLst>
+                    </p:cTn>
+                  </p:par>
+                  <p:par>
+                    <p:cTn id="77" fill="hold">
+                      <p:stCondLst>
+                        <p:cond delay="indefinite"/>
+                      </p:stCondLst>
+                      <p:childTnLst>
+                        <p:par>
+                          <p:cTn id="78" fill="hold">
+                            <p:stCondLst>
+                              <p:cond delay="0"/>
+                            </p:stCondLst>
+                            <p:childTnLst>
+                              <p:par>
+                                <p:cTn id="79" presetID="1" presetClass="entr" presetSubtype="0" fill="hold" grpId="0" nodeType="clickEffect">
+                                  <p:stCondLst>
+                                    <p:cond delay="0"/>
+                                  </p:stCondLst>
+                                  <p:childTnLst>
+                                    <p:set>
+                                      <p:cBhvr>
+                                        <p:cTn id="80" dur="1" fill="hold">
+                                          <p:stCondLst>
+                                            <p:cond delay="0"/>
+                                          </p:stCondLst>
+                                        </p:cTn>
+                                        <p:tgtEl>
+                                          <p:spTgt spid="37"/>
+                                        </p:tgtEl>
+                                        <p:attrNameLst>
+                                          <p:attrName>style.visibility</p:attrName>
+                                        </p:attrNameLst>
+                                      </p:cBhvr>
+                                      <p:to>
+                                        <p:strVal val="visible"/>
+                                      </p:to>
+                                    </p:set>
+                                  </p:childTnLst>
+                                </p:cTn>
+                              </p:par>
+                              <p:par>
+                                <p:cTn id="81" presetID="1" presetClass="entr" presetSubtype="0" fill="hold" grpId="0" nodeType="withEffect">
+                                  <p:stCondLst>
+                                    <p:cond delay="0"/>
+                                  </p:stCondLst>
+                                  <p:childTnLst>
+                                    <p:set>
+                                      <p:cBhvr>
+                                        <p:cTn id="82" dur="1" fill="hold">
+                                          <p:stCondLst>
+                                            <p:cond delay="0"/>
+                                          </p:stCondLst>
+                                        </p:cTn>
+                                        <p:tgtEl>
+                                          <p:spTgt spid="38"/>
+                                        </p:tgtEl>
+                                        <p:attrNameLst>
+                                          <p:attrName>style.visibility</p:attrName>
+                                        </p:attrNameLst>
+                                      </p:cBhvr>
+                                      <p:to>
+                                        <p:strVal val="visible"/>
+                                      </p:to>
+                                    </p:set>
+                                  </p:childTnLst>
+                                </p:cTn>
+                              </p:par>
+                              <p:par>
+                                <p:cTn id="83" presetID="1" presetClass="entr" presetSubtype="0" fill="hold" grpId="0" nodeType="withEffect">
+                                  <p:stCondLst>
+                                    <p:cond delay="0"/>
+                                  </p:stCondLst>
+                                  <p:childTnLst>
+                                    <p:set>
+                                      <p:cBhvr>
+                                        <p:cTn id="84" dur="1" fill="hold">
+                                          <p:stCondLst>
+                                            <p:cond delay="0"/>
+                                          </p:stCondLst>
+                                        </p:cTn>
+                                        <p:tgtEl>
+                                          <p:spTgt spid="39"/>
+                                        </p:tgtEl>
+                                        <p:attrNameLst>
+                                          <p:attrName>style.visibility</p:attrName>
+                                        </p:attrNameLst>
+                                      </p:cBhvr>
+                                      <p:to>
+                                        <p:strVal val="visible"/>
+                                      </p:to>
+                                    </p:set>
+                                  </p:childTnLst>
+                                </p:cTn>
+                              </p:par>
+                              <p:par>
+                                <p:cTn id="85" presetID="1" presetClass="entr" presetSubtype="0" fill="hold" grpId="0" nodeType="withEffect">
+                                  <p:stCondLst>
+                                    <p:cond delay="0"/>
+                                  </p:stCondLst>
+                                  <p:childTnLst>
+                                    <p:set>
+                                      <p:cBhvr>
+                                        <p:cTn id="86" dur="1" fill="hold">
+                                          <p:stCondLst>
+                                            <p:cond delay="0"/>
+                                          </p:stCondLst>
+                                        </p:cTn>
+                                        <p:tgtEl>
+                                          <p:spTgt spid="40"/>
+                                        </p:tgtEl>
+                                        <p:attrNameLst>
+                                          <p:attrName>style.visibility</p:attrName>
+                                        </p:attrNameLst>
+                                      </p:cBhvr>
+                                      <p:to>
+                                        <p:strVal val="visible"/>
+                                      </p:to>
+                                    </p:set>
+                                  </p:childTnLst>
+                                </p:cTn>
+                              </p:par>
+                              <p:par>
+                                <p:cTn id="87" presetID="1" presetClass="entr" presetSubtype="0" fill="hold" grpId="0" nodeType="withEffect">
+                                  <p:stCondLst>
+                                    <p:cond delay="0"/>
+                                  </p:stCondLst>
+                                  <p:childTnLst>
+                                    <p:set>
+                                      <p:cBhvr>
+                                        <p:cTn id="88" dur="1" fill="hold">
+                                          <p:stCondLst>
+                                            <p:cond delay="0"/>
+                                          </p:stCondLst>
+                                        </p:cTn>
+                                        <p:tgtEl>
+                                          <p:spTgt spid="41"/>
+                                        </p:tgtEl>
+                                        <p:attrNameLst>
+                                          <p:attrName>style.visibility</p:attrName>
+                                        </p:attrNameLst>
+                                      </p:cBhvr>
+                                      <p:to>
+                                        <p:strVal val="visible"/>
+                                      </p:to>
+                                    </p:set>
+                                  </p:childTnLst>
+                                </p:cTn>
+                              </p:par>
+                            </p:childTnLst>
+                          </p:cTn>
+                        </p:par>
+                      </p:childTnLst>
+                    </p:cTn>
+                  </p:par>
+                  <p:par>
+                    <p:cTn id="89" fill="hold">
+                      <p:stCondLst>
+                        <p:cond delay="indefinite"/>
+                      </p:stCondLst>
+                      <p:childTnLst>
+                        <p:par>
+                          <p:cTn id="90" fill="hold">
+                            <p:stCondLst>
+                              <p:cond delay="0"/>
+                            </p:stCondLst>
+                            <p:childTnLst>
+                              <p:par>
+                                <p:cTn id="91" presetID="1" presetClass="entr" presetSubtype="0" fill="hold" grpId="0" nodeType="clickEffect">
+                                  <p:stCondLst>
+                                    <p:cond delay="0"/>
+                                  </p:stCondLst>
+                                  <p:childTnLst>
+                                    <p:set>
+                                      <p:cBhvr>
+                                        <p:cTn id="92" dur="1" fill="hold">
+                                          <p:stCondLst>
+                                            <p:cond delay="0"/>
+                                          </p:stCondLst>
+                                        </p:cTn>
+                                        <p:tgtEl>
+                                          <p:spTgt spid="42"/>
+                                        </p:tgtEl>
+                                        <p:attrNameLst>
+                                          <p:attrName>style.visibility</p:attrName>
+                                        </p:attrNameLst>
+                                      </p:cBhvr>
+                                      <p:to>
+                                        <p:strVal val="visible"/>
+                                      </p:to>
+                                    </p:set>
+                                  </p:childTnLst>
+                                </p:cTn>
+                              </p:par>
+                              <p:par>
+                                <p:cTn id="93" presetID="1" presetClass="entr" presetSubtype="0" fill="hold" grpId="0" nodeType="withEffect">
+                                  <p:stCondLst>
+                                    <p:cond delay="0"/>
+                                  </p:stCondLst>
+                                  <p:childTnLst>
+                                    <p:set>
+                                      <p:cBhvr>
+                                        <p:cTn id="94" dur="1" fill="hold">
+                                          <p:stCondLst>
+                                            <p:cond delay="0"/>
+                                          </p:stCondLst>
+                                        </p:cTn>
+                                        <p:tgtEl>
+                                          <p:spTgt spid="43"/>
+                                        </p:tgtEl>
+                                        <p:attrNameLst>
+                                          <p:attrName>style.visibility</p:attrName>
+                                        </p:attrNameLst>
+                                      </p:cBhvr>
+                                      <p:to>
+                                        <p:strVal val="visible"/>
+                                      </p:to>
+                                    </p:set>
+                                  </p:childTnLst>
+                                </p:cTn>
+                              </p:par>
+                              <p:par>
+                                <p:cTn id="95" presetID="1" presetClass="entr" presetSubtype="0" fill="hold" grpId="0" nodeType="withEffect">
+                                  <p:stCondLst>
+                                    <p:cond delay="0"/>
+                                  </p:stCondLst>
+                                  <p:childTnLst>
+                                    <p:set>
+                                      <p:cBhvr>
+                                        <p:cTn id="96" dur="1" fill="hold">
+                                          <p:stCondLst>
+                                            <p:cond delay="0"/>
+                                          </p:stCondLst>
+                                        </p:cTn>
+                                        <p:tgtEl>
+                                          <p:spTgt spid="44"/>
+                                        </p:tgtEl>
+                                        <p:attrNameLst>
+                                          <p:attrName>style.visibility</p:attrName>
+                                        </p:attrNameLst>
+                                      </p:cBhvr>
+                                      <p:to>
+                                        <p:strVal val="visible"/>
+                                      </p:to>
+                                    </p:set>
+                                  </p:childTnLst>
+                                </p:cTn>
+                              </p:par>
+                              <p:par>
+                                <p:cTn id="97" presetID="1" presetClass="entr" presetSubtype="0" fill="hold" grpId="0" nodeType="withEffect">
+                                  <p:stCondLst>
+                                    <p:cond delay="0"/>
+                                  </p:stCondLst>
+                                  <p:childTnLst>
+                                    <p:set>
+                                      <p:cBhvr>
+                                        <p:cTn id="98" dur="1" fill="hold">
+                                          <p:stCondLst>
+                                            <p:cond delay="0"/>
+                                          </p:stCondLst>
+                                        </p:cTn>
+                                        <p:tgtEl>
+                                          <p:spTgt spid="45"/>
+                                        </p:tgtEl>
+                                        <p:attrNameLst>
+                                          <p:attrName>style.visibility</p:attrName>
+                                        </p:attrNameLst>
+                                      </p:cBhvr>
+                                      <p:to>
+                                        <p:strVal val="visible"/>
+                                      </p:to>
+                                    </p:set>
+                                  </p:childTnLst>
+                                </p:cTn>
+                              </p:par>
+                              <p:par>
+                                <p:cTn id="99" presetID="1" presetClass="entr" presetSubtype="0" fill="hold" grpId="0" nodeType="withEffect">
+                                  <p:stCondLst>
+                                    <p:cond delay="0"/>
+                                  </p:stCondLst>
+                                  <p:childTnLst>
+                                    <p:set>
+                                      <p:cBhvr>
+                                        <p:cTn id="100" dur="1" fill="hold">
+                                          <p:stCondLst>
+                                            <p:cond delay="0"/>
+                                          </p:stCondLst>
+                                        </p:cTn>
+                                        <p:tgtEl>
+                                          <p:spTgt spid="46"/>
+                                        </p:tgtEl>
+                                        <p:attrNameLst>
+                                          <p:attrName>style.visibility</p:attrName>
+                                        </p:attrNameLst>
+                                      </p:cBhvr>
+                                      <p:to>
+                                        <p:strVal val="visible"/>
+                                      </p:to>
+                                    </p:set>
+                                  </p:childTnLst>
+                                </p:cTn>
+                              </p:par>
+                            </p:childTnLst>
+                          </p:cTn>
+                        </p:par>
+                      </p:childTnLst>
+                    </p:cTn>
+                  </p:par>
+                  <p:par>
+                    <p:cTn id="101" fill="hold">
+                      <p:stCondLst>
+                        <p:cond delay="indefinite"/>
+                      </p:stCondLst>
+                      <p:childTnLst>
+                        <p:par>
+                          <p:cTn id="102" fill="hold">
+                            <p:stCondLst>
+                              <p:cond delay="0"/>
+                            </p:stCondLst>
+                            <p:childTnLst>
+                              <p:par>
+                                <p:cTn id="103" presetID="1" presetClass="entr" presetSubtype="0" fill="hold" grpId="0" nodeType="clickEffect">
+                                  <p:stCondLst>
+                                    <p:cond delay="0"/>
+                                  </p:stCondLst>
+                                  <p:childTnLst>
+                                    <p:set>
+                                      <p:cBhvr>
+                                        <p:cTn id="104" dur="1" fill="hold">
+                                          <p:stCondLst>
+                                            <p:cond delay="0"/>
+                                          </p:stCondLst>
+                                        </p:cTn>
+                                        <p:tgtEl>
+                                          <p:spTgt spid="47"/>
+                                        </p:tgtEl>
+                                        <p:attrNameLst>
+                                          <p:attrName>style.visibility</p:attrName>
+                                        </p:attrNameLst>
+                                      </p:cBhvr>
+                                      <p:to>
+                                        <p:strVal val="visible"/>
+                                      </p:to>
+                                    </p:set>
+                                  </p:childTnLst>
+                                </p:cTn>
+                              </p:par>
+                              <p:par>
+                                <p:cTn id="105" presetID="1" presetClass="entr" presetSubtype="0" fill="hold" grpId="0" nodeType="withEffect">
+                                  <p:stCondLst>
+                                    <p:cond delay="0"/>
+                                  </p:stCondLst>
+                                  <p:childTnLst>
+                                    <p:set>
+                                      <p:cBhvr>
+                                        <p:cTn id="106" dur="1" fill="hold">
+                                          <p:stCondLst>
+                                            <p:cond delay="0"/>
+                                          </p:stCondLst>
+                                        </p:cTn>
+                                        <p:tgtEl>
+                                          <p:spTgt spid="48"/>
+                                        </p:tgtEl>
+                                        <p:attrNameLst>
+                                          <p:attrName>style.visibility</p:attrName>
+                                        </p:attrNameLst>
+                                      </p:cBhvr>
+                                      <p:to>
+                                        <p:strVal val="visible"/>
+                                      </p:to>
+                                    </p:set>
+                                  </p:childTnLst>
+                                </p:cTn>
+                              </p:par>
+                              <p:par>
+                                <p:cTn id="107" presetID="1" presetClass="entr" presetSubtype="0" fill="hold" grpId="0" nodeType="withEffect">
+                                  <p:stCondLst>
+                                    <p:cond delay="0"/>
+                                  </p:stCondLst>
+                                  <p:childTnLst>
+                                    <p:set>
+                                      <p:cBhvr>
+                                        <p:cTn id="108" dur="1" fill="hold">
+                                          <p:stCondLst>
+                                            <p:cond delay="0"/>
+                                          </p:stCondLst>
+                                        </p:cTn>
+                                        <p:tgtEl>
+                                          <p:spTgt spid="49"/>
+                                        </p:tgtEl>
+                                        <p:attrNameLst>
+                                          <p:attrName>style.visibility</p:attrName>
+                                        </p:attrNameLst>
+                                      </p:cBhvr>
+                                      <p:to>
+                                        <p:strVal val="visible"/>
+                                      </p:to>
+                                    </p:set>
+                                  </p:childTnLst>
+                                </p:cTn>
+                              </p:par>
+                              <p:par>
+                                <p:cTn id="109" presetID="1" presetClass="entr" presetSubtype="0" fill="hold" grpId="0" nodeType="withEffect">
+                                  <p:stCondLst>
+                                    <p:cond delay="0"/>
+                                  </p:stCondLst>
+                                  <p:childTnLst>
+                                    <p:set>
+                                      <p:cBhvr>
+                                        <p:cTn id="110" dur="1" fill="hold">
+                                          <p:stCondLst>
+                                            <p:cond delay="0"/>
+                                          </p:stCondLst>
+                                        </p:cTn>
+                                        <p:tgtEl>
+                                          <p:spTgt spid="50"/>
+                                        </p:tgtEl>
+                                        <p:attrNameLst>
+                                          <p:attrName>style.visibility</p:attrName>
+                                        </p:attrNameLst>
+                                      </p:cBhvr>
+                                      <p:to>
+                                        <p:strVal val="visible"/>
+                                      </p:to>
+                                    </p:set>
+                                  </p:childTnLst>
+                                </p:cTn>
+                              </p:par>
+                              <p:par>
+                                <p:cTn id="111" presetID="1" presetClass="entr" presetSubtype="0" fill="hold" grpId="0" nodeType="withEffect">
+                                  <p:stCondLst>
+                                    <p:cond delay="0"/>
+                                  </p:stCondLst>
+                                  <p:childTnLst>
+                                    <p:set>
+                                      <p:cBhvr>
+                                        <p:cTn id="112" dur="1" fill="hold">
+                                          <p:stCondLst>
+                                            <p:cond delay="0"/>
+                                          </p:stCondLst>
+                                        </p:cTn>
+                                        <p:tgtEl>
+                                          <p:spTgt spid="51"/>
+                                        </p:tgtEl>
+                                        <p:attrNameLst>
+                                          <p:attrName>style.visibility</p:attrName>
+                                        </p:attrNameLst>
+                                      </p:cBhvr>
+                                      <p:to>
+                                        <p:strVal val="visible"/>
+                                      </p:to>
+                                    </p:set>
+                                  </p:childTnLst>
+                                </p:cTn>
+                              </p:par>
+                            </p:childTnLst>
+                          </p:cTn>
+                        </p:par>
+                      </p:childTnLst>
+                    </p:cTn>
+                  </p:par>
+                  <p:par>
+                    <p:cTn id="113" fill="hold">
+                      <p:stCondLst>
+                        <p:cond delay="indefinite"/>
+                      </p:stCondLst>
+                      <p:childTnLst>
+                        <p:par>
+                          <p:cTn id="114" fill="hold">
+                            <p:stCondLst>
+                              <p:cond delay="0"/>
+                            </p:stCondLst>
+                            <p:childTnLst>
+                              <p:par>
+                                <p:cTn id="115" presetID="1" presetClass="entr" presetSubtype="0" fill="hold" grpId="0" nodeType="clickEffect">
+                                  <p:stCondLst>
+                                    <p:cond delay="0"/>
+                                  </p:stCondLst>
+                                  <p:childTnLst>
+                                    <p:set>
+                                      <p:cBhvr>
+                                        <p:cTn id="116" dur="1" fill="hold">
+                                          <p:stCondLst>
+                                            <p:cond delay="0"/>
+                                          </p:stCondLst>
+                                        </p:cTn>
+                                        <p:tgtEl>
+                                          <p:spTgt spid="52"/>
+                                        </p:tgtEl>
+                                        <p:attrNameLst>
+                                          <p:attrName>style.visibility</p:attrName>
+                                        </p:attrNameLst>
+                                      </p:cBhvr>
+                                      <p:to>
+                                        <p:strVal val="visible"/>
+                                      </p:to>
+                                    </p:set>
+                                  </p:childTnLst>
+                                </p:cTn>
+                              </p:par>
+                              <p:par>
+                                <p:cTn id="117" presetID="1" presetClass="entr" presetSubtype="0" fill="hold" grpId="0" nodeType="withEffect">
+                                  <p:stCondLst>
+                                    <p:cond delay="0"/>
+                                  </p:stCondLst>
+                                  <p:childTnLst>
+                                    <p:set>
+                                      <p:cBhvr>
+                                        <p:cTn id="118" dur="1" fill="hold">
+                                          <p:stCondLst>
+                                            <p:cond delay="0"/>
+                                          </p:stCondLst>
+                                        </p:cTn>
+                                        <p:tgtEl>
+                                          <p:spTgt spid="53"/>
+                                        </p:tgtEl>
+                                        <p:attrNameLst>
+                                          <p:attrName>style.visibility</p:attrName>
+                                        </p:attrNameLst>
+                                      </p:cBhvr>
+                                      <p:to>
+                                        <p:strVal val="visible"/>
+                                      </p:to>
+                                    </p:set>
+                                  </p:childTnLst>
+                                </p:cTn>
+                              </p:par>
+                            </p:childTnLst>
+                          </p:cTn>
+                        </p:par>
+                      </p:childTnLst>
+                    </p:cTn>
+                  </p:par>
+                </p:childTnLst>
+              </p:cTn>
+              <p:prevCondLst>
+                <p:cond evt="onPrev" delay="0">
+                  <p:tgtEl>
+                    <p:sldTgt/>
+                  </p:tgtEl>
+                </p:cond>
+              </p:prevCondLst>
+              <p:nextCondLst>
+                <p:cond evt="onNext" delay="0">
+                  <p:tgtEl>
+                    <p:sldTgt/>
+                  </p:tgtEl>
+                </p:cond>
+              </p:nextCondLst>
+            </p:seq>
+          </p:childTnLst>
+        </p:cTn>
+      </p:par>
+    </p:tnLst>
+    <p:bldLst>
+      <p:bldP spid="7" grpId="0" animBg="1"/>
+      <p:bldP spid="8" grpId="0" animBg="1"/>
+      <p:bldP spid="9" grpId="0" animBg="1"/>
+      <p:bldP spid="10" grpId="0" animBg="1"/>
+      <p:bldP spid="11" grpId="0" animBg="1"/>
+      <p:bldP spid="12" grpId="0" animBg="1"/>
+      <p:bldP spid="13" grpId="0" animBg="1"/>
+      <p:bldP spid="14" grpId="0" animBg="1"/>
+      <p:bldP spid="15" grpId="0" animBg="1"/>
+      <p:bldP spid="16" grpId="0" animBg="1"/>
+      <p:bldP spid="17" grpId="0" animBg="1"/>
+      <p:bldP spid="18" grpId="0" animBg="1"/>
+      <p:bldP spid="19" grpId="0" animBg="1"/>
+      <p:bldP spid="20" grpId="0" animBg="1"/>
+      <p:bldP spid="21" grpId="0" animBg="1"/>
+      <p:bldP spid="22" grpId="0" animBg="1"/>
+      <p:bldP spid="23" grpId="0" animBg="1"/>
+      <p:bldP spid="24" grpId="0" animBg="1"/>
+      <p:bldP spid="25" grpId="0" animBg="1"/>
+      <p:bldP spid="26" grpId="0" animBg="1"/>
+      <p:bldP spid="27" grpId="0" animBg="1"/>
+      <p:bldP spid="28" grpId="0" animBg="1"/>
+      <p:bldP spid="29" grpId="0" animBg="1"/>
+      <p:bldP spid="30" grpId="0" animBg="1"/>
+      <p:bldP spid="31" grpId="0" animBg="1"/>
+      <p:bldP spid="32" grpId="0" animBg="1"/>
+      <p:bldP spid="33" grpId="0" animBg="1"/>
+      <p:bldP spid="34" grpId="0" animBg="1"/>
+      <p:bldP spid="35" grpId="0" animBg="1"/>
+      <p:bldP spid="36" grpId="0" animBg="1"/>
+      <p:bldP spid="37" grpId="0" animBg="1"/>
+      <p:bldP spid="38" grpId="0" animBg="1"/>
+      <p:bldP spid="39" grpId="0" animBg="1"/>
+      <p:bldP spid="40" grpId="0" animBg="1"/>
+      <p:bldP spid="41" grpId="0" animBg="1"/>
+      <p:bldP spid="42" grpId="0" animBg="1"/>
+      <p:bldP spid="43" grpId="0" animBg="1"/>
+      <p:bldP spid="44" grpId="0" animBg="1"/>
+      <p:bldP spid="45" grpId="0" animBg="1"/>
+      <p:bldP spid="46" grpId="0" animBg="1"/>
+      <p:bldP spid="47" grpId="0" animBg="1"/>
+      <p:bldP spid="48" grpId="0" animBg="1"/>
+      <p:bldP spid="49" grpId="0" animBg="1"/>
+      <p:bldP spid="50" grpId="0" animBg="1"/>
+      <p:bldP spid="51" grpId="0" animBg="1"/>
+      <p:bldP spid="52" grpId="0" animBg="1"/>
+      <p:bldP spid="53" grpId="0" animBg="1"/>
+    </p:bldLst>
+  </p:timing>
 </p:sld>
 </file>
 
@@ -24410,6 +25968,1131 @@
   <p:clrMapOvr>
     <a:masterClrMapping/>
   </p:clrMapOvr>
+  <p:timing>
+    <p:tnLst>
+      <p:par>
+        <p:cTn id="1" dur="indefinite" restart="never" nodeType="tmRoot">
+          <p:childTnLst>
+            <p:seq concurrent="1" nextAc="seek">
+              <p:cTn id="2" dur="indefinite" nodeType="mainSeq">
+                <p:childTnLst>
+                  <p:par>
+                    <p:cTn id="3" fill="hold">
+                      <p:stCondLst>
+                        <p:cond delay="indefinite"/>
+                      </p:stCondLst>
+                      <p:childTnLst>
+                        <p:par>
+                          <p:cTn id="4" fill="hold">
+                            <p:stCondLst>
+                              <p:cond delay="0"/>
+                            </p:stCondLst>
+                            <p:childTnLst>
+                              <p:par>
+                                <p:cTn id="5" presetID="1" presetClass="entr" presetSubtype="0" fill="hold" grpId="0" nodeType="clickEffect">
+                                  <p:stCondLst>
+                                    <p:cond delay="0"/>
+                                  </p:stCondLst>
+                                  <p:childTnLst>
+                                    <p:set>
+                                      <p:cBhvr>
+                                        <p:cTn id="6" dur="1" fill="hold">
+                                          <p:stCondLst>
+                                            <p:cond delay="0"/>
+                                          </p:stCondLst>
+                                        </p:cTn>
+                                        <p:tgtEl>
+                                          <p:spTgt spid="7"/>
+                                        </p:tgtEl>
+                                        <p:attrNameLst>
+                                          <p:attrName>style.visibility</p:attrName>
+                                        </p:attrNameLst>
+                                      </p:cBhvr>
+                                      <p:to>
+                                        <p:strVal val="visible"/>
+                                      </p:to>
+                                    </p:set>
+                                  </p:childTnLst>
+                                </p:cTn>
+                              </p:par>
+                              <p:par>
+                                <p:cTn id="7" presetID="1" presetClass="entr" presetSubtype="0" fill="hold" grpId="0" nodeType="withEffect">
+                                  <p:stCondLst>
+                                    <p:cond delay="0"/>
+                                  </p:stCondLst>
+                                  <p:childTnLst>
+                                    <p:set>
+                                      <p:cBhvr>
+                                        <p:cTn id="8" dur="1" fill="hold">
+                                          <p:stCondLst>
+                                            <p:cond delay="0"/>
+                                          </p:stCondLst>
+                                        </p:cTn>
+                                        <p:tgtEl>
+                                          <p:spTgt spid="8"/>
+                                        </p:tgtEl>
+                                        <p:attrNameLst>
+                                          <p:attrName>style.visibility</p:attrName>
+                                        </p:attrNameLst>
+                                      </p:cBhvr>
+                                      <p:to>
+                                        <p:strVal val="visible"/>
+                                      </p:to>
+                                    </p:set>
+                                  </p:childTnLst>
+                                </p:cTn>
+                              </p:par>
+                              <p:par>
+                                <p:cTn id="9" presetID="1" presetClass="entr" presetSubtype="0" fill="hold" grpId="0" nodeType="withEffect">
+                                  <p:stCondLst>
+                                    <p:cond delay="0"/>
+                                  </p:stCondLst>
+                                  <p:childTnLst>
+                                    <p:set>
+                                      <p:cBhvr>
+                                        <p:cTn id="10" dur="1" fill="hold">
+                                          <p:stCondLst>
+                                            <p:cond delay="0"/>
+                                          </p:stCondLst>
+                                        </p:cTn>
+                                        <p:tgtEl>
+                                          <p:spTgt spid="25"/>
+                                        </p:tgtEl>
+                                        <p:attrNameLst>
+                                          <p:attrName>style.visibility</p:attrName>
+                                        </p:attrNameLst>
+                                      </p:cBhvr>
+                                      <p:to>
+                                        <p:strVal val="visible"/>
+                                      </p:to>
+                                    </p:set>
+                                  </p:childTnLst>
+                                </p:cTn>
+                              </p:par>
+                            </p:childTnLst>
+                          </p:cTn>
+                        </p:par>
+                      </p:childTnLst>
+                    </p:cTn>
+                  </p:par>
+                  <p:par>
+                    <p:cTn id="11" fill="hold">
+                      <p:stCondLst>
+                        <p:cond delay="indefinite"/>
+                      </p:stCondLst>
+                      <p:childTnLst>
+                        <p:par>
+                          <p:cTn id="12" fill="hold">
+                            <p:stCondLst>
+                              <p:cond delay="0"/>
+                            </p:stCondLst>
+                            <p:childTnLst>
+                              <p:par>
+                                <p:cTn id="13" presetID="1" presetClass="entr" presetSubtype="0" fill="hold" grpId="0" nodeType="clickEffect">
+                                  <p:stCondLst>
+                                    <p:cond delay="0"/>
+                                  </p:stCondLst>
+                                  <p:childTnLst>
+                                    <p:set>
+                                      <p:cBhvr>
+                                        <p:cTn id="14" dur="1" fill="hold">
+                                          <p:stCondLst>
+                                            <p:cond delay="0"/>
+                                          </p:stCondLst>
+                                        </p:cTn>
+                                        <p:tgtEl>
+                                          <p:spTgt spid="9"/>
+                                        </p:tgtEl>
+                                        <p:attrNameLst>
+                                          <p:attrName>style.visibility</p:attrName>
+                                        </p:attrNameLst>
+                                      </p:cBhvr>
+                                      <p:to>
+                                        <p:strVal val="visible"/>
+                                      </p:to>
+                                    </p:set>
+                                  </p:childTnLst>
+                                </p:cTn>
+                              </p:par>
+                              <p:par>
+                                <p:cTn id="15" presetID="1" presetClass="entr" presetSubtype="0" fill="hold" grpId="0" nodeType="withEffect">
+                                  <p:stCondLst>
+                                    <p:cond delay="0"/>
+                                  </p:stCondLst>
+                                  <p:childTnLst>
+                                    <p:set>
+                                      <p:cBhvr>
+                                        <p:cTn id="16" dur="1" fill="hold">
+                                          <p:stCondLst>
+                                            <p:cond delay="0"/>
+                                          </p:stCondLst>
+                                        </p:cTn>
+                                        <p:tgtEl>
+                                          <p:spTgt spid="10"/>
+                                        </p:tgtEl>
+                                        <p:attrNameLst>
+                                          <p:attrName>style.visibility</p:attrName>
+                                        </p:attrNameLst>
+                                      </p:cBhvr>
+                                      <p:to>
+                                        <p:strVal val="visible"/>
+                                      </p:to>
+                                    </p:set>
+                                  </p:childTnLst>
+                                </p:cTn>
+                              </p:par>
+                              <p:par>
+                                <p:cTn id="17" presetID="1" presetClass="entr" presetSubtype="0" fill="hold" grpId="0" nodeType="withEffect">
+                                  <p:stCondLst>
+                                    <p:cond delay="0"/>
+                                  </p:stCondLst>
+                                  <p:childTnLst>
+                                    <p:set>
+                                      <p:cBhvr>
+                                        <p:cTn id="18" dur="1" fill="hold">
+                                          <p:stCondLst>
+                                            <p:cond delay="0"/>
+                                          </p:stCondLst>
+                                        </p:cTn>
+                                        <p:tgtEl>
+                                          <p:spTgt spid="26"/>
+                                        </p:tgtEl>
+                                        <p:attrNameLst>
+                                          <p:attrName>style.visibility</p:attrName>
+                                        </p:attrNameLst>
+                                      </p:cBhvr>
+                                      <p:to>
+                                        <p:strVal val="visible"/>
+                                      </p:to>
+                                    </p:set>
+                                  </p:childTnLst>
+                                </p:cTn>
+                              </p:par>
+                            </p:childTnLst>
+                          </p:cTn>
+                        </p:par>
+                      </p:childTnLst>
+                    </p:cTn>
+                  </p:par>
+                  <p:par>
+                    <p:cTn id="19" fill="hold">
+                      <p:stCondLst>
+                        <p:cond delay="indefinite"/>
+                      </p:stCondLst>
+                      <p:childTnLst>
+                        <p:par>
+                          <p:cTn id="20" fill="hold">
+                            <p:stCondLst>
+                              <p:cond delay="0"/>
+                            </p:stCondLst>
+                            <p:childTnLst>
+                              <p:par>
+                                <p:cTn id="21" presetID="1" presetClass="entr" presetSubtype="0" fill="hold" grpId="0" nodeType="clickEffect">
+                                  <p:stCondLst>
+                                    <p:cond delay="0"/>
+                                  </p:stCondLst>
+                                  <p:childTnLst>
+                                    <p:set>
+                                      <p:cBhvr>
+                                        <p:cTn id="22" dur="1" fill="hold">
+                                          <p:stCondLst>
+                                            <p:cond delay="0"/>
+                                          </p:stCondLst>
+                                        </p:cTn>
+                                        <p:tgtEl>
+                                          <p:spTgt spid="11"/>
+                                        </p:tgtEl>
+                                        <p:attrNameLst>
+                                          <p:attrName>style.visibility</p:attrName>
+                                        </p:attrNameLst>
+                                      </p:cBhvr>
+                                      <p:to>
+                                        <p:strVal val="visible"/>
+                                      </p:to>
+                                    </p:set>
+                                  </p:childTnLst>
+                                </p:cTn>
+                              </p:par>
+                              <p:par>
+                                <p:cTn id="23" presetID="1" presetClass="entr" presetSubtype="0" fill="hold" grpId="0" nodeType="withEffect">
+                                  <p:stCondLst>
+                                    <p:cond delay="0"/>
+                                  </p:stCondLst>
+                                  <p:childTnLst>
+                                    <p:set>
+                                      <p:cBhvr>
+                                        <p:cTn id="24" dur="1" fill="hold">
+                                          <p:stCondLst>
+                                            <p:cond delay="0"/>
+                                          </p:stCondLst>
+                                        </p:cTn>
+                                        <p:tgtEl>
+                                          <p:spTgt spid="12"/>
+                                        </p:tgtEl>
+                                        <p:attrNameLst>
+                                          <p:attrName>style.visibility</p:attrName>
+                                        </p:attrNameLst>
+                                      </p:cBhvr>
+                                      <p:to>
+                                        <p:strVal val="visible"/>
+                                      </p:to>
+                                    </p:set>
+                                  </p:childTnLst>
+                                </p:cTn>
+                              </p:par>
+                              <p:par>
+                                <p:cTn id="25" presetID="1" presetClass="entr" presetSubtype="0" fill="hold" grpId="0" nodeType="withEffect">
+                                  <p:stCondLst>
+                                    <p:cond delay="0"/>
+                                  </p:stCondLst>
+                                  <p:childTnLst>
+                                    <p:set>
+                                      <p:cBhvr>
+                                        <p:cTn id="26" dur="1" fill="hold">
+                                          <p:stCondLst>
+                                            <p:cond delay="0"/>
+                                          </p:stCondLst>
+                                        </p:cTn>
+                                        <p:tgtEl>
+                                          <p:spTgt spid="27"/>
+                                        </p:tgtEl>
+                                        <p:attrNameLst>
+                                          <p:attrName>style.visibility</p:attrName>
+                                        </p:attrNameLst>
+                                      </p:cBhvr>
+                                      <p:to>
+                                        <p:strVal val="visible"/>
+                                      </p:to>
+                                    </p:set>
+                                  </p:childTnLst>
+                                </p:cTn>
+                              </p:par>
+                            </p:childTnLst>
+                          </p:cTn>
+                        </p:par>
+                      </p:childTnLst>
+                    </p:cTn>
+                  </p:par>
+                  <p:par>
+                    <p:cTn id="27" fill="hold">
+                      <p:stCondLst>
+                        <p:cond delay="indefinite"/>
+                      </p:stCondLst>
+                      <p:childTnLst>
+                        <p:par>
+                          <p:cTn id="28" fill="hold">
+                            <p:stCondLst>
+                              <p:cond delay="0"/>
+                            </p:stCondLst>
+                            <p:childTnLst>
+                              <p:par>
+                                <p:cTn id="29" presetID="1" presetClass="entr" presetSubtype="0" fill="hold" grpId="0" nodeType="clickEffect">
+                                  <p:stCondLst>
+                                    <p:cond delay="0"/>
+                                  </p:stCondLst>
+                                  <p:childTnLst>
+                                    <p:set>
+                                      <p:cBhvr>
+                                        <p:cTn id="30" dur="1" fill="hold">
+                                          <p:stCondLst>
+                                            <p:cond delay="0"/>
+                                          </p:stCondLst>
+                                        </p:cTn>
+                                        <p:tgtEl>
+                                          <p:spTgt spid="13"/>
+                                        </p:tgtEl>
+                                        <p:attrNameLst>
+                                          <p:attrName>style.visibility</p:attrName>
+                                        </p:attrNameLst>
+                                      </p:cBhvr>
+                                      <p:to>
+                                        <p:strVal val="visible"/>
+                                      </p:to>
+                                    </p:set>
+                                  </p:childTnLst>
+                                </p:cTn>
+                              </p:par>
+                              <p:par>
+                                <p:cTn id="31" presetID="1" presetClass="entr" presetSubtype="0" fill="hold" grpId="0" nodeType="withEffect">
+                                  <p:stCondLst>
+                                    <p:cond delay="0"/>
+                                  </p:stCondLst>
+                                  <p:childTnLst>
+                                    <p:set>
+                                      <p:cBhvr>
+                                        <p:cTn id="32" dur="1" fill="hold">
+                                          <p:stCondLst>
+                                            <p:cond delay="0"/>
+                                          </p:stCondLst>
+                                        </p:cTn>
+                                        <p:tgtEl>
+                                          <p:spTgt spid="14"/>
+                                        </p:tgtEl>
+                                        <p:attrNameLst>
+                                          <p:attrName>style.visibility</p:attrName>
+                                        </p:attrNameLst>
+                                      </p:cBhvr>
+                                      <p:to>
+                                        <p:strVal val="visible"/>
+                                      </p:to>
+                                    </p:set>
+                                  </p:childTnLst>
+                                </p:cTn>
+                              </p:par>
+                              <p:par>
+                                <p:cTn id="33" presetID="1" presetClass="entr" presetSubtype="0" fill="hold" grpId="0" nodeType="withEffect">
+                                  <p:stCondLst>
+                                    <p:cond delay="0"/>
+                                  </p:stCondLst>
+                                  <p:childTnLst>
+                                    <p:set>
+                                      <p:cBhvr>
+                                        <p:cTn id="34" dur="1" fill="hold">
+                                          <p:stCondLst>
+                                            <p:cond delay="0"/>
+                                          </p:stCondLst>
+                                        </p:cTn>
+                                        <p:tgtEl>
+                                          <p:spTgt spid="28"/>
+                                        </p:tgtEl>
+                                        <p:attrNameLst>
+                                          <p:attrName>style.visibility</p:attrName>
+                                        </p:attrNameLst>
+                                      </p:cBhvr>
+                                      <p:to>
+                                        <p:strVal val="visible"/>
+                                      </p:to>
+                                    </p:set>
+                                  </p:childTnLst>
+                                </p:cTn>
+                              </p:par>
+                            </p:childTnLst>
+                          </p:cTn>
+                        </p:par>
+                      </p:childTnLst>
+                    </p:cTn>
+                  </p:par>
+                  <p:par>
+                    <p:cTn id="35" fill="hold">
+                      <p:stCondLst>
+                        <p:cond delay="indefinite"/>
+                      </p:stCondLst>
+                      <p:childTnLst>
+                        <p:par>
+                          <p:cTn id="36" fill="hold">
+                            <p:stCondLst>
+                              <p:cond delay="0"/>
+                            </p:stCondLst>
+                            <p:childTnLst>
+                              <p:par>
+                                <p:cTn id="37" presetID="1" presetClass="entr" presetSubtype="0" fill="hold" grpId="0" nodeType="clickEffect">
+                                  <p:stCondLst>
+                                    <p:cond delay="0"/>
+                                  </p:stCondLst>
+                                  <p:childTnLst>
+                                    <p:set>
+                                      <p:cBhvr>
+                                        <p:cTn id="38" dur="1" fill="hold">
+                                          <p:stCondLst>
+                                            <p:cond delay="0"/>
+                                          </p:stCondLst>
+                                        </p:cTn>
+                                        <p:tgtEl>
+                                          <p:spTgt spid="15"/>
+                                        </p:tgtEl>
+                                        <p:attrNameLst>
+                                          <p:attrName>style.visibility</p:attrName>
+                                        </p:attrNameLst>
+                                      </p:cBhvr>
+                                      <p:to>
+                                        <p:strVal val="visible"/>
+                                      </p:to>
+                                    </p:set>
+                                  </p:childTnLst>
+                                </p:cTn>
+                              </p:par>
+                              <p:par>
+                                <p:cTn id="39" presetID="1" presetClass="entr" presetSubtype="0" fill="hold" grpId="0" nodeType="withEffect">
+                                  <p:stCondLst>
+                                    <p:cond delay="0"/>
+                                  </p:stCondLst>
+                                  <p:childTnLst>
+                                    <p:set>
+                                      <p:cBhvr>
+                                        <p:cTn id="40" dur="1" fill="hold">
+                                          <p:stCondLst>
+                                            <p:cond delay="0"/>
+                                          </p:stCondLst>
+                                        </p:cTn>
+                                        <p:tgtEl>
+                                          <p:spTgt spid="16"/>
+                                        </p:tgtEl>
+                                        <p:attrNameLst>
+                                          <p:attrName>style.visibility</p:attrName>
+                                        </p:attrNameLst>
+                                      </p:cBhvr>
+                                      <p:to>
+                                        <p:strVal val="visible"/>
+                                      </p:to>
+                                    </p:set>
+                                  </p:childTnLst>
+                                </p:cTn>
+                              </p:par>
+                              <p:par>
+                                <p:cTn id="41" presetID="1" presetClass="entr" presetSubtype="0" fill="hold" grpId="0" nodeType="withEffect">
+                                  <p:stCondLst>
+                                    <p:cond delay="0"/>
+                                  </p:stCondLst>
+                                  <p:childTnLst>
+                                    <p:set>
+                                      <p:cBhvr>
+                                        <p:cTn id="42" dur="1" fill="hold">
+                                          <p:stCondLst>
+                                            <p:cond delay="0"/>
+                                          </p:stCondLst>
+                                        </p:cTn>
+                                        <p:tgtEl>
+                                          <p:spTgt spid="29"/>
+                                        </p:tgtEl>
+                                        <p:attrNameLst>
+                                          <p:attrName>style.visibility</p:attrName>
+                                        </p:attrNameLst>
+                                      </p:cBhvr>
+                                      <p:to>
+                                        <p:strVal val="visible"/>
+                                      </p:to>
+                                    </p:set>
+                                  </p:childTnLst>
+                                </p:cTn>
+                              </p:par>
+                            </p:childTnLst>
+                          </p:cTn>
+                        </p:par>
+                      </p:childTnLst>
+                    </p:cTn>
+                  </p:par>
+                  <p:par>
+                    <p:cTn id="43" fill="hold">
+                      <p:stCondLst>
+                        <p:cond delay="indefinite"/>
+                      </p:stCondLst>
+                      <p:childTnLst>
+                        <p:par>
+                          <p:cTn id="44" fill="hold">
+                            <p:stCondLst>
+                              <p:cond delay="0"/>
+                            </p:stCondLst>
+                            <p:childTnLst>
+                              <p:par>
+                                <p:cTn id="45" presetID="1" presetClass="entr" presetSubtype="0" fill="hold" grpId="0" nodeType="clickEffect">
+                                  <p:stCondLst>
+                                    <p:cond delay="0"/>
+                                  </p:stCondLst>
+                                  <p:childTnLst>
+                                    <p:set>
+                                      <p:cBhvr>
+                                        <p:cTn id="46" dur="1" fill="hold">
+                                          <p:stCondLst>
+                                            <p:cond delay="0"/>
+                                          </p:stCondLst>
+                                        </p:cTn>
+                                        <p:tgtEl>
+                                          <p:spTgt spid="17"/>
+                                        </p:tgtEl>
+                                        <p:attrNameLst>
+                                          <p:attrName>style.visibility</p:attrName>
+                                        </p:attrNameLst>
+                                      </p:cBhvr>
+                                      <p:to>
+                                        <p:strVal val="visible"/>
+                                      </p:to>
+                                    </p:set>
+                                  </p:childTnLst>
+                                </p:cTn>
+                              </p:par>
+                              <p:par>
+                                <p:cTn id="47" presetID="1" presetClass="entr" presetSubtype="0" fill="hold" grpId="0" nodeType="withEffect">
+                                  <p:stCondLst>
+                                    <p:cond delay="0"/>
+                                  </p:stCondLst>
+                                  <p:childTnLst>
+                                    <p:set>
+                                      <p:cBhvr>
+                                        <p:cTn id="48" dur="1" fill="hold">
+                                          <p:stCondLst>
+                                            <p:cond delay="0"/>
+                                          </p:stCondLst>
+                                        </p:cTn>
+                                        <p:tgtEl>
+                                          <p:spTgt spid="18"/>
+                                        </p:tgtEl>
+                                        <p:attrNameLst>
+                                          <p:attrName>style.visibility</p:attrName>
+                                        </p:attrNameLst>
+                                      </p:cBhvr>
+                                      <p:to>
+                                        <p:strVal val="visible"/>
+                                      </p:to>
+                                    </p:set>
+                                  </p:childTnLst>
+                                </p:cTn>
+                              </p:par>
+                              <p:par>
+                                <p:cTn id="49" presetID="1" presetClass="entr" presetSubtype="0" fill="hold" grpId="0" nodeType="withEffect">
+                                  <p:stCondLst>
+                                    <p:cond delay="0"/>
+                                  </p:stCondLst>
+                                  <p:childTnLst>
+                                    <p:set>
+                                      <p:cBhvr>
+                                        <p:cTn id="50" dur="1" fill="hold">
+                                          <p:stCondLst>
+                                            <p:cond delay="0"/>
+                                          </p:stCondLst>
+                                        </p:cTn>
+                                        <p:tgtEl>
+                                          <p:spTgt spid="30"/>
+                                        </p:tgtEl>
+                                        <p:attrNameLst>
+                                          <p:attrName>style.visibility</p:attrName>
+                                        </p:attrNameLst>
+                                      </p:cBhvr>
+                                      <p:to>
+                                        <p:strVal val="visible"/>
+                                      </p:to>
+                                    </p:set>
+                                  </p:childTnLst>
+                                </p:cTn>
+                              </p:par>
+                            </p:childTnLst>
+                          </p:cTn>
+                        </p:par>
+                      </p:childTnLst>
+                    </p:cTn>
+                  </p:par>
+                  <p:par>
+                    <p:cTn id="51" fill="hold">
+                      <p:stCondLst>
+                        <p:cond delay="indefinite"/>
+                      </p:stCondLst>
+                      <p:childTnLst>
+                        <p:par>
+                          <p:cTn id="52" fill="hold">
+                            <p:stCondLst>
+                              <p:cond delay="0"/>
+                            </p:stCondLst>
+                            <p:childTnLst>
+                              <p:par>
+                                <p:cTn id="53" presetID="1" presetClass="entr" presetSubtype="0" fill="hold" grpId="0" nodeType="clickEffect">
+                                  <p:stCondLst>
+                                    <p:cond delay="0"/>
+                                  </p:stCondLst>
+                                  <p:childTnLst>
+                                    <p:set>
+                                      <p:cBhvr>
+                                        <p:cTn id="54" dur="1" fill="hold">
+                                          <p:stCondLst>
+                                            <p:cond delay="0"/>
+                                          </p:stCondLst>
+                                        </p:cTn>
+                                        <p:tgtEl>
+                                          <p:spTgt spid="19"/>
+                                        </p:tgtEl>
+                                        <p:attrNameLst>
+                                          <p:attrName>style.visibility</p:attrName>
+                                        </p:attrNameLst>
+                                      </p:cBhvr>
+                                      <p:to>
+                                        <p:strVal val="visible"/>
+                                      </p:to>
+                                    </p:set>
+                                  </p:childTnLst>
+                                </p:cTn>
+                              </p:par>
+                              <p:par>
+                                <p:cTn id="55" presetID="1" presetClass="entr" presetSubtype="0" fill="hold" grpId="0" nodeType="withEffect">
+                                  <p:stCondLst>
+                                    <p:cond delay="0"/>
+                                  </p:stCondLst>
+                                  <p:childTnLst>
+                                    <p:set>
+                                      <p:cBhvr>
+                                        <p:cTn id="56" dur="1" fill="hold">
+                                          <p:stCondLst>
+                                            <p:cond delay="0"/>
+                                          </p:stCondLst>
+                                        </p:cTn>
+                                        <p:tgtEl>
+                                          <p:spTgt spid="20"/>
+                                        </p:tgtEl>
+                                        <p:attrNameLst>
+                                          <p:attrName>style.visibility</p:attrName>
+                                        </p:attrNameLst>
+                                      </p:cBhvr>
+                                      <p:to>
+                                        <p:strVal val="visible"/>
+                                      </p:to>
+                                    </p:set>
+                                  </p:childTnLst>
+                                </p:cTn>
+                              </p:par>
+                              <p:par>
+                                <p:cTn id="57" presetID="1" presetClass="entr" presetSubtype="0" fill="hold" grpId="0" nodeType="withEffect">
+                                  <p:stCondLst>
+                                    <p:cond delay="0"/>
+                                  </p:stCondLst>
+                                  <p:childTnLst>
+                                    <p:set>
+                                      <p:cBhvr>
+                                        <p:cTn id="58" dur="1" fill="hold">
+                                          <p:stCondLst>
+                                            <p:cond delay="0"/>
+                                          </p:stCondLst>
+                                        </p:cTn>
+                                        <p:tgtEl>
+                                          <p:spTgt spid="31"/>
+                                        </p:tgtEl>
+                                        <p:attrNameLst>
+                                          <p:attrName>style.visibility</p:attrName>
+                                        </p:attrNameLst>
+                                      </p:cBhvr>
+                                      <p:to>
+                                        <p:strVal val="visible"/>
+                                      </p:to>
+                                    </p:set>
+                                  </p:childTnLst>
+                                </p:cTn>
+                              </p:par>
+                            </p:childTnLst>
+                          </p:cTn>
+                        </p:par>
+                      </p:childTnLst>
+                    </p:cTn>
+                  </p:par>
+                  <p:par>
+                    <p:cTn id="59" fill="hold">
+                      <p:stCondLst>
+                        <p:cond delay="indefinite"/>
+                      </p:stCondLst>
+                      <p:childTnLst>
+                        <p:par>
+                          <p:cTn id="60" fill="hold">
+                            <p:stCondLst>
+                              <p:cond delay="0"/>
+                            </p:stCondLst>
+                            <p:childTnLst>
+                              <p:par>
+                                <p:cTn id="61" presetID="1" presetClass="entr" presetSubtype="0" fill="hold" grpId="0" nodeType="clickEffect">
+                                  <p:stCondLst>
+                                    <p:cond delay="0"/>
+                                  </p:stCondLst>
+                                  <p:childTnLst>
+                                    <p:set>
+                                      <p:cBhvr>
+                                        <p:cTn id="62" dur="1" fill="hold">
+                                          <p:stCondLst>
+                                            <p:cond delay="0"/>
+                                          </p:stCondLst>
+                                        </p:cTn>
+                                        <p:tgtEl>
+                                          <p:spTgt spid="21"/>
+                                        </p:tgtEl>
+                                        <p:attrNameLst>
+                                          <p:attrName>style.visibility</p:attrName>
+                                        </p:attrNameLst>
+                                      </p:cBhvr>
+                                      <p:to>
+                                        <p:strVal val="visible"/>
+                                      </p:to>
+                                    </p:set>
+                                  </p:childTnLst>
+                                </p:cTn>
+                              </p:par>
+                              <p:par>
+                                <p:cTn id="63" presetID="1" presetClass="entr" presetSubtype="0" fill="hold" grpId="0" nodeType="withEffect">
+                                  <p:stCondLst>
+                                    <p:cond delay="0"/>
+                                  </p:stCondLst>
+                                  <p:childTnLst>
+                                    <p:set>
+                                      <p:cBhvr>
+                                        <p:cTn id="64" dur="1" fill="hold">
+                                          <p:stCondLst>
+                                            <p:cond delay="0"/>
+                                          </p:stCondLst>
+                                        </p:cTn>
+                                        <p:tgtEl>
+                                          <p:spTgt spid="22"/>
+                                        </p:tgtEl>
+                                        <p:attrNameLst>
+                                          <p:attrName>style.visibility</p:attrName>
+                                        </p:attrNameLst>
+                                      </p:cBhvr>
+                                      <p:to>
+                                        <p:strVal val="visible"/>
+                                      </p:to>
+                                    </p:set>
+                                  </p:childTnLst>
+                                </p:cTn>
+                              </p:par>
+                              <p:par>
+                                <p:cTn id="65" presetID="1" presetClass="entr" presetSubtype="0" fill="hold" grpId="0" nodeType="withEffect">
+                                  <p:stCondLst>
+                                    <p:cond delay="0"/>
+                                  </p:stCondLst>
+                                  <p:childTnLst>
+                                    <p:set>
+                                      <p:cBhvr>
+                                        <p:cTn id="66" dur="1" fill="hold">
+                                          <p:stCondLst>
+                                            <p:cond delay="0"/>
+                                          </p:stCondLst>
+                                        </p:cTn>
+                                        <p:tgtEl>
+                                          <p:spTgt spid="32"/>
+                                        </p:tgtEl>
+                                        <p:attrNameLst>
+                                          <p:attrName>style.visibility</p:attrName>
+                                        </p:attrNameLst>
+                                      </p:cBhvr>
+                                      <p:to>
+                                        <p:strVal val="visible"/>
+                                      </p:to>
+                                    </p:set>
+                                  </p:childTnLst>
+                                </p:cTn>
+                              </p:par>
+                            </p:childTnLst>
+                          </p:cTn>
+                        </p:par>
+                      </p:childTnLst>
+                    </p:cTn>
+                  </p:par>
+                  <p:par>
+                    <p:cTn id="67" fill="hold">
+                      <p:stCondLst>
+                        <p:cond delay="indefinite"/>
+                      </p:stCondLst>
+                      <p:childTnLst>
+                        <p:par>
+                          <p:cTn id="68" fill="hold">
+                            <p:stCondLst>
+                              <p:cond delay="0"/>
+                            </p:stCondLst>
+                            <p:childTnLst>
+                              <p:par>
+                                <p:cTn id="69" presetID="1" presetClass="entr" presetSubtype="0" fill="hold" grpId="0" nodeType="clickEffect">
+                                  <p:stCondLst>
+                                    <p:cond delay="0"/>
+                                  </p:stCondLst>
+                                  <p:childTnLst>
+                                    <p:set>
+                                      <p:cBhvr>
+                                        <p:cTn id="70" dur="1" fill="hold">
+                                          <p:stCondLst>
+                                            <p:cond delay="0"/>
+                                          </p:stCondLst>
+                                        </p:cTn>
+                                        <p:tgtEl>
+                                          <p:spTgt spid="23"/>
+                                        </p:tgtEl>
+                                        <p:attrNameLst>
+                                          <p:attrName>style.visibility</p:attrName>
+                                        </p:attrNameLst>
+                                      </p:cBhvr>
+                                      <p:to>
+                                        <p:strVal val="visible"/>
+                                      </p:to>
+                                    </p:set>
+                                  </p:childTnLst>
+                                </p:cTn>
+                              </p:par>
+                              <p:par>
+                                <p:cTn id="71" presetID="1" presetClass="entr" presetSubtype="0" fill="hold" grpId="0" nodeType="withEffect">
+                                  <p:stCondLst>
+                                    <p:cond delay="0"/>
+                                  </p:stCondLst>
+                                  <p:childTnLst>
+                                    <p:set>
+                                      <p:cBhvr>
+                                        <p:cTn id="72" dur="1" fill="hold">
+                                          <p:stCondLst>
+                                            <p:cond delay="0"/>
+                                          </p:stCondLst>
+                                        </p:cTn>
+                                        <p:tgtEl>
+                                          <p:spTgt spid="24"/>
+                                        </p:tgtEl>
+                                        <p:attrNameLst>
+                                          <p:attrName>style.visibility</p:attrName>
+                                        </p:attrNameLst>
+                                      </p:cBhvr>
+                                      <p:to>
+                                        <p:strVal val="visible"/>
+                                      </p:to>
+                                    </p:set>
+                                  </p:childTnLst>
+                                </p:cTn>
+                              </p:par>
+                              <p:par>
+                                <p:cTn id="73" presetID="1" presetClass="entr" presetSubtype="0" fill="hold" grpId="0" nodeType="withEffect">
+                                  <p:stCondLst>
+                                    <p:cond delay="0"/>
+                                  </p:stCondLst>
+                                  <p:childTnLst>
+                                    <p:set>
+                                      <p:cBhvr>
+                                        <p:cTn id="74" dur="1" fill="hold">
+                                          <p:stCondLst>
+                                            <p:cond delay="0"/>
+                                          </p:stCondLst>
+                                        </p:cTn>
+                                        <p:tgtEl>
+                                          <p:spTgt spid="33"/>
+                                        </p:tgtEl>
+                                        <p:attrNameLst>
+                                          <p:attrName>style.visibility</p:attrName>
+                                        </p:attrNameLst>
+                                      </p:cBhvr>
+                                      <p:to>
+                                        <p:strVal val="visible"/>
+                                      </p:to>
+                                    </p:set>
+                                  </p:childTnLst>
+                                </p:cTn>
+                              </p:par>
+                            </p:childTnLst>
+                          </p:cTn>
+                        </p:par>
+                      </p:childTnLst>
+                    </p:cTn>
+                  </p:par>
+                  <p:par>
+                    <p:cTn id="75" fill="hold">
+                      <p:stCondLst>
+                        <p:cond delay="indefinite"/>
+                      </p:stCondLst>
+                      <p:childTnLst>
+                        <p:par>
+                          <p:cTn id="76" fill="hold">
+                            <p:stCondLst>
+                              <p:cond delay="0"/>
+                            </p:stCondLst>
+                            <p:childTnLst>
+                              <p:par>
+                                <p:cTn id="77" presetID="1" presetClass="entr" presetSubtype="0" fill="hold" grpId="0" nodeType="clickEffect">
+                                  <p:stCondLst>
+                                    <p:cond delay="0"/>
+                                  </p:stCondLst>
+                                  <p:childTnLst>
+                                    <p:set>
+                                      <p:cBhvr>
+                                        <p:cTn id="78" dur="1" fill="hold">
+                                          <p:stCondLst>
+                                            <p:cond delay="0"/>
+                                          </p:stCondLst>
+                                        </p:cTn>
+                                        <p:tgtEl>
+                                          <p:spTgt spid="34"/>
+                                        </p:tgtEl>
+                                        <p:attrNameLst>
+                                          <p:attrName>style.visibility</p:attrName>
+                                        </p:attrNameLst>
+                                      </p:cBhvr>
+                                      <p:to>
+                                        <p:strVal val="visible"/>
+                                      </p:to>
+                                    </p:set>
+                                  </p:childTnLst>
+                                </p:cTn>
+                              </p:par>
+                              <p:par>
+                                <p:cTn id="79" presetID="1" presetClass="entr" presetSubtype="0" fill="hold" grpId="0" nodeType="withEffect">
+                                  <p:stCondLst>
+                                    <p:cond delay="0"/>
+                                  </p:stCondLst>
+                                  <p:childTnLst>
+                                    <p:set>
+                                      <p:cBhvr>
+                                        <p:cTn id="80" dur="1" fill="hold">
+                                          <p:stCondLst>
+                                            <p:cond delay="0"/>
+                                          </p:stCondLst>
+                                        </p:cTn>
+                                        <p:tgtEl>
+                                          <p:spTgt spid="35"/>
+                                        </p:tgtEl>
+                                        <p:attrNameLst>
+                                          <p:attrName>style.visibility</p:attrName>
+                                        </p:attrNameLst>
+                                      </p:cBhvr>
+                                      <p:to>
+                                        <p:strVal val="visible"/>
+                                      </p:to>
+                                    </p:set>
+                                  </p:childTnLst>
+                                </p:cTn>
+                              </p:par>
+                            </p:childTnLst>
+                          </p:cTn>
+                        </p:par>
+                      </p:childTnLst>
+                    </p:cTn>
+                  </p:par>
+                  <p:par>
+                    <p:cTn id="81" fill="hold">
+                      <p:stCondLst>
+                        <p:cond delay="indefinite"/>
+                      </p:stCondLst>
+                      <p:childTnLst>
+                        <p:par>
+                          <p:cTn id="82" fill="hold">
+                            <p:stCondLst>
+                              <p:cond delay="0"/>
+                            </p:stCondLst>
+                            <p:childTnLst>
+                              <p:par>
+                                <p:cTn id="83" presetID="1" presetClass="entr" presetSubtype="0" fill="hold" grpId="0" nodeType="clickEffect">
+                                  <p:stCondLst>
+                                    <p:cond delay="0"/>
+                                  </p:stCondLst>
+                                  <p:childTnLst>
+                                    <p:set>
+                                      <p:cBhvr>
+                                        <p:cTn id="84" dur="1" fill="hold">
+                                          <p:stCondLst>
+                                            <p:cond delay="0"/>
+                                          </p:stCondLst>
+                                        </p:cTn>
+                                        <p:tgtEl>
+                                          <p:spTgt spid="36"/>
+                                        </p:tgtEl>
+                                        <p:attrNameLst>
+                                          <p:attrName>style.visibility</p:attrName>
+                                        </p:attrNameLst>
+                                      </p:cBhvr>
+                                      <p:to>
+                                        <p:strVal val="visible"/>
+                                      </p:to>
+                                    </p:set>
+                                  </p:childTnLst>
+                                </p:cTn>
+                              </p:par>
+                              <p:par>
+                                <p:cTn id="85" presetID="1" presetClass="entr" presetSubtype="0" fill="hold" nodeType="withEffect">
+                                  <p:stCondLst>
+                                    <p:cond delay="0"/>
+                                  </p:stCondLst>
+                                  <p:childTnLst>
+                                    <p:set>
+                                      <p:cBhvr>
+                                        <p:cTn id="86" dur="1" fill="hold">
+                                          <p:stCondLst>
+                                            <p:cond delay="0"/>
+                                          </p:stCondLst>
+                                        </p:cTn>
+                                        <p:tgtEl>
+                                          <p:spTgt spid="37"/>
+                                        </p:tgtEl>
+                                        <p:attrNameLst>
+                                          <p:attrName>style.visibility</p:attrName>
+                                        </p:attrNameLst>
+                                      </p:cBhvr>
+                                      <p:to>
+                                        <p:strVal val="visible"/>
+                                      </p:to>
+                                    </p:set>
+                                  </p:childTnLst>
+                                </p:cTn>
+                              </p:par>
+                              <p:par>
+                                <p:cTn id="87" presetID="1" presetClass="entr" presetSubtype="0" fill="hold" grpId="0" nodeType="withEffect">
+                                  <p:stCondLst>
+                                    <p:cond delay="0"/>
+                                  </p:stCondLst>
+                                  <p:childTnLst>
+                                    <p:set>
+                                      <p:cBhvr>
+                                        <p:cTn id="88" dur="1" fill="hold">
+                                          <p:stCondLst>
+                                            <p:cond delay="0"/>
+                                          </p:stCondLst>
+                                        </p:cTn>
+                                        <p:tgtEl>
+                                          <p:spTgt spid="38"/>
+                                        </p:tgtEl>
+                                        <p:attrNameLst>
+                                          <p:attrName>style.visibility</p:attrName>
+                                        </p:attrNameLst>
+                                      </p:cBhvr>
+                                      <p:to>
+                                        <p:strVal val="visible"/>
+                                      </p:to>
+                                    </p:set>
+                                  </p:childTnLst>
+                                </p:cTn>
+                              </p:par>
+                            </p:childTnLst>
+                          </p:cTn>
+                        </p:par>
+                      </p:childTnLst>
+                    </p:cTn>
+                  </p:par>
+                </p:childTnLst>
+              </p:cTn>
+              <p:prevCondLst>
+                <p:cond evt="onPrev" delay="0">
+                  <p:tgtEl>
+                    <p:sldTgt/>
+                  </p:tgtEl>
+                </p:cond>
+              </p:prevCondLst>
+              <p:nextCondLst>
+                <p:cond evt="onNext" delay="0">
+                  <p:tgtEl>
+                    <p:sldTgt/>
+                  </p:tgtEl>
+                </p:cond>
+              </p:nextCondLst>
+            </p:seq>
+          </p:childTnLst>
+        </p:cTn>
+      </p:par>
+    </p:tnLst>
+    <p:bldLst>
+      <p:bldP spid="7" grpId="0" animBg="1"/>
+      <p:bldP spid="8" grpId="0" animBg="1"/>
+      <p:bldP spid="9" grpId="0" animBg="1"/>
+      <p:bldP spid="10" grpId="0" animBg="1"/>
+      <p:bldP spid="11" grpId="0" animBg="1"/>
+      <p:bldP spid="12" grpId="0" animBg="1"/>
+      <p:bldP spid="13" grpId="0" animBg="1"/>
+      <p:bldP spid="14" grpId="0" animBg="1"/>
+      <p:bldP spid="15" grpId="0" animBg="1"/>
+      <p:bldP spid="16" grpId="0" animBg="1"/>
+      <p:bldP spid="17" grpId="0" animBg="1"/>
+      <p:bldP spid="18" grpId="0" animBg="1"/>
+      <p:bldP spid="19" grpId="0" animBg="1"/>
+      <p:bldP spid="20" grpId="0" animBg="1"/>
+      <p:bldP spid="21" grpId="0" animBg="1"/>
+      <p:bldP spid="22" grpId="0" animBg="1"/>
+      <p:bldP spid="23" grpId="0" animBg="1"/>
+      <p:bldP spid="24" grpId="0" animBg="1"/>
+      <p:bldP spid="25" grpId="0" animBg="1"/>
+      <p:bldP spid="26" grpId="0" animBg="1"/>
+      <p:bldP spid="27" grpId="0" animBg="1"/>
+      <p:bldP spid="28" grpId="0" animBg="1"/>
+      <p:bldP spid="29" grpId="0" animBg="1"/>
+      <p:bldP spid="30" grpId="0" animBg="1"/>
+      <p:bldP spid="31" grpId="0" animBg="1"/>
+      <p:bldP spid="32" grpId="0" animBg="1"/>
+      <p:bldP spid="33" grpId="0" animBg="1"/>
+      <p:bldP spid="34" grpId="0" animBg="1"/>
+      <p:bldP spid="35" grpId="0" animBg="1"/>
+      <p:bldP spid="36" grpId="0" animBg="1"/>
+      <p:bldP spid="38" grpId="0" animBg="1"/>
+    </p:bldLst>
+  </p:timing>
 </p:sld>
 </file>
 
@@ -25576,6 +28259,767 @@
   <p:clrMapOvr>
     <a:masterClrMapping/>
   </p:clrMapOvr>
+  <p:timing>
+    <p:tnLst>
+      <p:par>
+        <p:cTn id="1" dur="indefinite" restart="never" nodeType="tmRoot">
+          <p:childTnLst>
+            <p:seq concurrent="1" nextAc="seek">
+              <p:cTn id="2" dur="indefinite" nodeType="mainSeq">
+                <p:childTnLst>
+                  <p:par>
+                    <p:cTn id="3" fill="hold">
+                      <p:stCondLst>
+                        <p:cond delay="indefinite"/>
+                      </p:stCondLst>
+                      <p:childTnLst>
+                        <p:par>
+                          <p:cTn id="4" fill="hold">
+                            <p:stCondLst>
+                              <p:cond delay="0"/>
+                            </p:stCondLst>
+                            <p:childTnLst>
+                              <p:par>
+                                <p:cTn id="5" presetID="1" presetClass="entr" presetSubtype="0" fill="hold" grpId="0" nodeType="clickEffect">
+                                  <p:stCondLst>
+                                    <p:cond delay="0"/>
+                                  </p:stCondLst>
+                                  <p:childTnLst>
+                                    <p:set>
+                                      <p:cBhvr>
+                                        <p:cTn id="6" dur="1" fill="hold">
+                                          <p:stCondLst>
+                                            <p:cond delay="0"/>
+                                          </p:stCondLst>
+                                        </p:cTn>
+                                        <p:tgtEl>
+                                          <p:spTgt spid="7"/>
+                                        </p:tgtEl>
+                                        <p:attrNameLst>
+                                          <p:attrName>style.visibility</p:attrName>
+                                        </p:attrNameLst>
+                                      </p:cBhvr>
+                                      <p:to>
+                                        <p:strVal val="visible"/>
+                                      </p:to>
+                                    </p:set>
+                                  </p:childTnLst>
+                                </p:cTn>
+                              </p:par>
+                              <p:par>
+                                <p:cTn id="7" presetID="1" presetClass="entr" presetSubtype="0" fill="hold" grpId="0" nodeType="withEffect">
+                                  <p:stCondLst>
+                                    <p:cond delay="0"/>
+                                  </p:stCondLst>
+                                  <p:childTnLst>
+                                    <p:set>
+                                      <p:cBhvr>
+                                        <p:cTn id="8" dur="1" fill="hold">
+                                          <p:stCondLst>
+                                            <p:cond delay="0"/>
+                                          </p:stCondLst>
+                                        </p:cTn>
+                                        <p:tgtEl>
+                                          <p:spTgt spid="8"/>
+                                        </p:tgtEl>
+                                        <p:attrNameLst>
+                                          <p:attrName>style.visibility</p:attrName>
+                                        </p:attrNameLst>
+                                      </p:cBhvr>
+                                      <p:to>
+                                        <p:strVal val="visible"/>
+                                      </p:to>
+                                    </p:set>
+                                  </p:childTnLst>
+                                </p:cTn>
+                              </p:par>
+                              <p:par>
+                                <p:cTn id="9" presetID="1" presetClass="entr" presetSubtype="0" fill="hold" nodeType="withEffect">
+                                  <p:stCondLst>
+                                    <p:cond delay="0"/>
+                                  </p:stCondLst>
+                                  <p:childTnLst>
+                                    <p:set>
+                                      <p:cBhvr>
+                                        <p:cTn id="10" dur="1" fill="hold">
+                                          <p:stCondLst>
+                                            <p:cond delay="0"/>
+                                          </p:stCondLst>
+                                        </p:cTn>
+                                        <p:tgtEl>
+                                          <p:spTgt spid="9"/>
+                                        </p:tgtEl>
+                                        <p:attrNameLst>
+                                          <p:attrName>style.visibility</p:attrName>
+                                        </p:attrNameLst>
+                                      </p:cBhvr>
+                                      <p:to>
+                                        <p:strVal val="visible"/>
+                                      </p:to>
+                                    </p:set>
+                                  </p:childTnLst>
+                                </p:cTn>
+                              </p:par>
+                              <p:par>
+                                <p:cTn id="11" presetID="1" presetClass="entr" presetSubtype="0" fill="hold" grpId="0" nodeType="withEffect">
+                                  <p:stCondLst>
+                                    <p:cond delay="0"/>
+                                  </p:stCondLst>
+                                  <p:childTnLst>
+                                    <p:set>
+                                      <p:cBhvr>
+                                        <p:cTn id="12" dur="1" fill="hold">
+                                          <p:stCondLst>
+                                            <p:cond delay="0"/>
+                                          </p:stCondLst>
+                                        </p:cTn>
+                                        <p:tgtEl>
+                                          <p:spTgt spid="10"/>
+                                        </p:tgtEl>
+                                        <p:attrNameLst>
+                                          <p:attrName>style.visibility</p:attrName>
+                                        </p:attrNameLst>
+                                      </p:cBhvr>
+                                      <p:to>
+                                        <p:strVal val="visible"/>
+                                      </p:to>
+                                    </p:set>
+                                  </p:childTnLst>
+                                </p:cTn>
+                              </p:par>
+                              <p:par>
+                                <p:cTn id="13" presetID="1" presetClass="entr" presetSubtype="0" fill="hold" grpId="0" nodeType="withEffect">
+                                  <p:stCondLst>
+                                    <p:cond delay="0"/>
+                                  </p:stCondLst>
+                                  <p:childTnLst>
+                                    <p:set>
+                                      <p:cBhvr>
+                                        <p:cTn id="14" dur="1" fill="hold">
+                                          <p:stCondLst>
+                                            <p:cond delay="0"/>
+                                          </p:stCondLst>
+                                        </p:cTn>
+                                        <p:tgtEl>
+                                          <p:spTgt spid="11"/>
+                                        </p:tgtEl>
+                                        <p:attrNameLst>
+                                          <p:attrName>style.visibility</p:attrName>
+                                        </p:attrNameLst>
+                                      </p:cBhvr>
+                                      <p:to>
+                                        <p:strVal val="visible"/>
+                                      </p:to>
+                                    </p:set>
+                                  </p:childTnLst>
+                                </p:cTn>
+                              </p:par>
+                            </p:childTnLst>
+                          </p:cTn>
+                        </p:par>
+                      </p:childTnLst>
+                    </p:cTn>
+                  </p:par>
+                  <p:par>
+                    <p:cTn id="15" fill="hold">
+                      <p:stCondLst>
+                        <p:cond delay="indefinite"/>
+                      </p:stCondLst>
+                      <p:childTnLst>
+                        <p:par>
+                          <p:cTn id="16" fill="hold">
+                            <p:stCondLst>
+                              <p:cond delay="0"/>
+                            </p:stCondLst>
+                            <p:childTnLst>
+                              <p:par>
+                                <p:cTn id="17" presetID="1" presetClass="entr" presetSubtype="0" fill="hold" grpId="0" nodeType="clickEffect">
+                                  <p:stCondLst>
+                                    <p:cond delay="0"/>
+                                  </p:stCondLst>
+                                  <p:childTnLst>
+                                    <p:set>
+                                      <p:cBhvr>
+                                        <p:cTn id="18" dur="1" fill="hold">
+                                          <p:stCondLst>
+                                            <p:cond delay="0"/>
+                                          </p:stCondLst>
+                                        </p:cTn>
+                                        <p:tgtEl>
+                                          <p:spTgt spid="17"/>
+                                        </p:tgtEl>
+                                        <p:attrNameLst>
+                                          <p:attrName>style.visibility</p:attrName>
+                                        </p:attrNameLst>
+                                      </p:cBhvr>
+                                      <p:to>
+                                        <p:strVal val="visible"/>
+                                      </p:to>
+                                    </p:set>
+                                  </p:childTnLst>
+                                </p:cTn>
+                              </p:par>
+                              <p:par>
+                                <p:cTn id="19" presetID="1" presetClass="entr" presetSubtype="0" fill="hold" grpId="0" nodeType="withEffect">
+                                  <p:stCondLst>
+                                    <p:cond delay="0"/>
+                                  </p:stCondLst>
+                                  <p:childTnLst>
+                                    <p:set>
+                                      <p:cBhvr>
+                                        <p:cTn id="20" dur="1" fill="hold">
+                                          <p:stCondLst>
+                                            <p:cond delay="0"/>
+                                          </p:stCondLst>
+                                        </p:cTn>
+                                        <p:tgtEl>
+                                          <p:spTgt spid="18"/>
+                                        </p:tgtEl>
+                                        <p:attrNameLst>
+                                          <p:attrName>style.visibility</p:attrName>
+                                        </p:attrNameLst>
+                                      </p:cBhvr>
+                                      <p:to>
+                                        <p:strVal val="visible"/>
+                                      </p:to>
+                                    </p:set>
+                                  </p:childTnLst>
+                                </p:cTn>
+                              </p:par>
+                              <p:par>
+                                <p:cTn id="21" presetID="1" presetClass="entr" presetSubtype="0" fill="hold" nodeType="withEffect">
+                                  <p:stCondLst>
+                                    <p:cond delay="0"/>
+                                  </p:stCondLst>
+                                  <p:childTnLst>
+                                    <p:set>
+                                      <p:cBhvr>
+                                        <p:cTn id="22" dur="1" fill="hold">
+                                          <p:stCondLst>
+                                            <p:cond delay="0"/>
+                                          </p:stCondLst>
+                                        </p:cTn>
+                                        <p:tgtEl>
+                                          <p:spTgt spid="19"/>
+                                        </p:tgtEl>
+                                        <p:attrNameLst>
+                                          <p:attrName>style.visibility</p:attrName>
+                                        </p:attrNameLst>
+                                      </p:cBhvr>
+                                      <p:to>
+                                        <p:strVal val="visible"/>
+                                      </p:to>
+                                    </p:set>
+                                  </p:childTnLst>
+                                </p:cTn>
+                              </p:par>
+                              <p:par>
+                                <p:cTn id="23" presetID="1" presetClass="entr" presetSubtype="0" fill="hold" grpId="0" nodeType="withEffect">
+                                  <p:stCondLst>
+                                    <p:cond delay="0"/>
+                                  </p:stCondLst>
+                                  <p:childTnLst>
+                                    <p:set>
+                                      <p:cBhvr>
+                                        <p:cTn id="24" dur="1" fill="hold">
+                                          <p:stCondLst>
+                                            <p:cond delay="0"/>
+                                          </p:stCondLst>
+                                        </p:cTn>
+                                        <p:tgtEl>
+                                          <p:spTgt spid="20"/>
+                                        </p:tgtEl>
+                                        <p:attrNameLst>
+                                          <p:attrName>style.visibility</p:attrName>
+                                        </p:attrNameLst>
+                                      </p:cBhvr>
+                                      <p:to>
+                                        <p:strVal val="visible"/>
+                                      </p:to>
+                                    </p:set>
+                                  </p:childTnLst>
+                                </p:cTn>
+                              </p:par>
+                              <p:par>
+                                <p:cTn id="25" presetID="1" presetClass="entr" presetSubtype="0" fill="hold" grpId="0" nodeType="withEffect">
+                                  <p:stCondLst>
+                                    <p:cond delay="0"/>
+                                  </p:stCondLst>
+                                  <p:childTnLst>
+                                    <p:set>
+                                      <p:cBhvr>
+                                        <p:cTn id="26" dur="1" fill="hold">
+                                          <p:stCondLst>
+                                            <p:cond delay="0"/>
+                                          </p:stCondLst>
+                                        </p:cTn>
+                                        <p:tgtEl>
+                                          <p:spTgt spid="21"/>
+                                        </p:tgtEl>
+                                        <p:attrNameLst>
+                                          <p:attrName>style.visibility</p:attrName>
+                                        </p:attrNameLst>
+                                      </p:cBhvr>
+                                      <p:to>
+                                        <p:strVal val="visible"/>
+                                      </p:to>
+                                    </p:set>
+                                  </p:childTnLst>
+                                </p:cTn>
+                              </p:par>
+                            </p:childTnLst>
+                          </p:cTn>
+                        </p:par>
+                      </p:childTnLst>
+                    </p:cTn>
+                  </p:par>
+                  <p:par>
+                    <p:cTn id="27" fill="hold">
+                      <p:stCondLst>
+                        <p:cond delay="indefinite"/>
+                      </p:stCondLst>
+                      <p:childTnLst>
+                        <p:par>
+                          <p:cTn id="28" fill="hold">
+                            <p:stCondLst>
+                              <p:cond delay="0"/>
+                            </p:stCondLst>
+                            <p:childTnLst>
+                              <p:par>
+                                <p:cTn id="29" presetID="1" presetClass="entr" presetSubtype="0" fill="hold" grpId="0" nodeType="clickEffect">
+                                  <p:stCondLst>
+                                    <p:cond delay="0"/>
+                                  </p:stCondLst>
+                                  <p:childTnLst>
+                                    <p:set>
+                                      <p:cBhvr>
+                                        <p:cTn id="30" dur="1" fill="hold">
+                                          <p:stCondLst>
+                                            <p:cond delay="0"/>
+                                          </p:stCondLst>
+                                        </p:cTn>
+                                        <p:tgtEl>
+                                          <p:spTgt spid="12"/>
+                                        </p:tgtEl>
+                                        <p:attrNameLst>
+                                          <p:attrName>style.visibility</p:attrName>
+                                        </p:attrNameLst>
+                                      </p:cBhvr>
+                                      <p:to>
+                                        <p:strVal val="visible"/>
+                                      </p:to>
+                                    </p:set>
+                                  </p:childTnLst>
+                                </p:cTn>
+                              </p:par>
+                              <p:par>
+                                <p:cTn id="31" presetID="1" presetClass="entr" presetSubtype="0" fill="hold" grpId="0" nodeType="withEffect">
+                                  <p:stCondLst>
+                                    <p:cond delay="0"/>
+                                  </p:stCondLst>
+                                  <p:childTnLst>
+                                    <p:set>
+                                      <p:cBhvr>
+                                        <p:cTn id="32" dur="1" fill="hold">
+                                          <p:stCondLst>
+                                            <p:cond delay="0"/>
+                                          </p:stCondLst>
+                                        </p:cTn>
+                                        <p:tgtEl>
+                                          <p:spTgt spid="13"/>
+                                        </p:tgtEl>
+                                        <p:attrNameLst>
+                                          <p:attrName>style.visibility</p:attrName>
+                                        </p:attrNameLst>
+                                      </p:cBhvr>
+                                      <p:to>
+                                        <p:strVal val="visible"/>
+                                      </p:to>
+                                    </p:set>
+                                  </p:childTnLst>
+                                </p:cTn>
+                              </p:par>
+                              <p:par>
+                                <p:cTn id="33" presetID="1" presetClass="entr" presetSubtype="0" fill="hold" nodeType="withEffect">
+                                  <p:stCondLst>
+                                    <p:cond delay="0"/>
+                                  </p:stCondLst>
+                                  <p:childTnLst>
+                                    <p:set>
+                                      <p:cBhvr>
+                                        <p:cTn id="34" dur="1" fill="hold">
+                                          <p:stCondLst>
+                                            <p:cond delay="0"/>
+                                          </p:stCondLst>
+                                        </p:cTn>
+                                        <p:tgtEl>
+                                          <p:spTgt spid="14"/>
+                                        </p:tgtEl>
+                                        <p:attrNameLst>
+                                          <p:attrName>style.visibility</p:attrName>
+                                        </p:attrNameLst>
+                                      </p:cBhvr>
+                                      <p:to>
+                                        <p:strVal val="visible"/>
+                                      </p:to>
+                                    </p:set>
+                                  </p:childTnLst>
+                                </p:cTn>
+                              </p:par>
+                              <p:par>
+                                <p:cTn id="35" presetID="1" presetClass="entr" presetSubtype="0" fill="hold" grpId="0" nodeType="withEffect">
+                                  <p:stCondLst>
+                                    <p:cond delay="0"/>
+                                  </p:stCondLst>
+                                  <p:childTnLst>
+                                    <p:set>
+                                      <p:cBhvr>
+                                        <p:cTn id="36" dur="1" fill="hold">
+                                          <p:stCondLst>
+                                            <p:cond delay="0"/>
+                                          </p:stCondLst>
+                                        </p:cTn>
+                                        <p:tgtEl>
+                                          <p:spTgt spid="15"/>
+                                        </p:tgtEl>
+                                        <p:attrNameLst>
+                                          <p:attrName>style.visibility</p:attrName>
+                                        </p:attrNameLst>
+                                      </p:cBhvr>
+                                      <p:to>
+                                        <p:strVal val="visible"/>
+                                      </p:to>
+                                    </p:set>
+                                  </p:childTnLst>
+                                </p:cTn>
+                              </p:par>
+                              <p:par>
+                                <p:cTn id="37" presetID="1" presetClass="entr" presetSubtype="0" fill="hold" grpId="0" nodeType="withEffect">
+                                  <p:stCondLst>
+                                    <p:cond delay="0"/>
+                                  </p:stCondLst>
+                                  <p:childTnLst>
+                                    <p:set>
+                                      <p:cBhvr>
+                                        <p:cTn id="38" dur="1" fill="hold">
+                                          <p:stCondLst>
+                                            <p:cond delay="0"/>
+                                          </p:stCondLst>
+                                        </p:cTn>
+                                        <p:tgtEl>
+                                          <p:spTgt spid="16"/>
+                                        </p:tgtEl>
+                                        <p:attrNameLst>
+                                          <p:attrName>style.visibility</p:attrName>
+                                        </p:attrNameLst>
+                                      </p:cBhvr>
+                                      <p:to>
+                                        <p:strVal val="visible"/>
+                                      </p:to>
+                                    </p:set>
+                                  </p:childTnLst>
+                                </p:cTn>
+                              </p:par>
+                            </p:childTnLst>
+                          </p:cTn>
+                        </p:par>
+                      </p:childTnLst>
+                    </p:cTn>
+                  </p:par>
+                  <p:par>
+                    <p:cTn id="39" fill="hold">
+                      <p:stCondLst>
+                        <p:cond delay="indefinite"/>
+                      </p:stCondLst>
+                      <p:childTnLst>
+                        <p:par>
+                          <p:cTn id="40" fill="hold">
+                            <p:stCondLst>
+                              <p:cond delay="0"/>
+                            </p:stCondLst>
+                            <p:childTnLst>
+                              <p:par>
+                                <p:cTn id="41" presetID="1" presetClass="entr" presetSubtype="0" fill="hold" grpId="0" nodeType="clickEffect">
+                                  <p:stCondLst>
+                                    <p:cond delay="0"/>
+                                  </p:stCondLst>
+                                  <p:childTnLst>
+                                    <p:set>
+                                      <p:cBhvr>
+                                        <p:cTn id="42" dur="1" fill="hold">
+                                          <p:stCondLst>
+                                            <p:cond delay="0"/>
+                                          </p:stCondLst>
+                                        </p:cTn>
+                                        <p:tgtEl>
+                                          <p:spTgt spid="22"/>
+                                        </p:tgtEl>
+                                        <p:attrNameLst>
+                                          <p:attrName>style.visibility</p:attrName>
+                                        </p:attrNameLst>
+                                      </p:cBhvr>
+                                      <p:to>
+                                        <p:strVal val="visible"/>
+                                      </p:to>
+                                    </p:set>
+                                  </p:childTnLst>
+                                </p:cTn>
+                              </p:par>
+                              <p:par>
+                                <p:cTn id="43" presetID="1" presetClass="entr" presetSubtype="0" fill="hold" grpId="0" nodeType="withEffect">
+                                  <p:stCondLst>
+                                    <p:cond delay="0"/>
+                                  </p:stCondLst>
+                                  <p:childTnLst>
+                                    <p:set>
+                                      <p:cBhvr>
+                                        <p:cTn id="44" dur="1" fill="hold">
+                                          <p:stCondLst>
+                                            <p:cond delay="0"/>
+                                          </p:stCondLst>
+                                        </p:cTn>
+                                        <p:tgtEl>
+                                          <p:spTgt spid="23"/>
+                                        </p:tgtEl>
+                                        <p:attrNameLst>
+                                          <p:attrName>style.visibility</p:attrName>
+                                        </p:attrNameLst>
+                                      </p:cBhvr>
+                                      <p:to>
+                                        <p:strVal val="visible"/>
+                                      </p:to>
+                                    </p:set>
+                                  </p:childTnLst>
+                                </p:cTn>
+                              </p:par>
+                              <p:par>
+                                <p:cTn id="45" presetID="1" presetClass="entr" presetSubtype="0" fill="hold" nodeType="withEffect">
+                                  <p:stCondLst>
+                                    <p:cond delay="0"/>
+                                  </p:stCondLst>
+                                  <p:childTnLst>
+                                    <p:set>
+                                      <p:cBhvr>
+                                        <p:cTn id="46" dur="1" fill="hold">
+                                          <p:stCondLst>
+                                            <p:cond delay="0"/>
+                                          </p:stCondLst>
+                                        </p:cTn>
+                                        <p:tgtEl>
+                                          <p:spTgt spid="24"/>
+                                        </p:tgtEl>
+                                        <p:attrNameLst>
+                                          <p:attrName>style.visibility</p:attrName>
+                                        </p:attrNameLst>
+                                      </p:cBhvr>
+                                      <p:to>
+                                        <p:strVal val="visible"/>
+                                      </p:to>
+                                    </p:set>
+                                  </p:childTnLst>
+                                </p:cTn>
+                              </p:par>
+                              <p:par>
+                                <p:cTn id="47" presetID="1" presetClass="entr" presetSubtype="0" fill="hold" grpId="0" nodeType="withEffect">
+                                  <p:stCondLst>
+                                    <p:cond delay="0"/>
+                                  </p:stCondLst>
+                                  <p:childTnLst>
+                                    <p:set>
+                                      <p:cBhvr>
+                                        <p:cTn id="48" dur="1" fill="hold">
+                                          <p:stCondLst>
+                                            <p:cond delay="0"/>
+                                          </p:stCondLst>
+                                        </p:cTn>
+                                        <p:tgtEl>
+                                          <p:spTgt spid="25"/>
+                                        </p:tgtEl>
+                                        <p:attrNameLst>
+                                          <p:attrName>style.visibility</p:attrName>
+                                        </p:attrNameLst>
+                                      </p:cBhvr>
+                                      <p:to>
+                                        <p:strVal val="visible"/>
+                                      </p:to>
+                                    </p:set>
+                                  </p:childTnLst>
+                                </p:cTn>
+                              </p:par>
+                              <p:par>
+                                <p:cTn id="49" presetID="1" presetClass="entr" presetSubtype="0" fill="hold" grpId="0" nodeType="withEffect">
+                                  <p:stCondLst>
+                                    <p:cond delay="0"/>
+                                  </p:stCondLst>
+                                  <p:childTnLst>
+                                    <p:set>
+                                      <p:cBhvr>
+                                        <p:cTn id="50" dur="1" fill="hold">
+                                          <p:stCondLst>
+                                            <p:cond delay="0"/>
+                                          </p:stCondLst>
+                                        </p:cTn>
+                                        <p:tgtEl>
+                                          <p:spTgt spid="26"/>
+                                        </p:tgtEl>
+                                        <p:attrNameLst>
+                                          <p:attrName>style.visibility</p:attrName>
+                                        </p:attrNameLst>
+                                      </p:cBhvr>
+                                      <p:to>
+                                        <p:strVal val="visible"/>
+                                      </p:to>
+                                    </p:set>
+                                  </p:childTnLst>
+                                </p:cTn>
+                              </p:par>
+                            </p:childTnLst>
+                          </p:cTn>
+                        </p:par>
+                      </p:childTnLst>
+                    </p:cTn>
+                  </p:par>
+                  <p:par>
+                    <p:cTn id="51" fill="hold">
+                      <p:stCondLst>
+                        <p:cond delay="indefinite"/>
+                      </p:stCondLst>
+                      <p:childTnLst>
+                        <p:par>
+                          <p:cTn id="52" fill="hold">
+                            <p:stCondLst>
+                              <p:cond delay="0"/>
+                            </p:stCondLst>
+                            <p:childTnLst>
+                              <p:par>
+                                <p:cTn id="53" presetID="1" presetClass="entr" presetSubtype="0" fill="hold" grpId="0" nodeType="clickEffect">
+                                  <p:stCondLst>
+                                    <p:cond delay="0"/>
+                                  </p:stCondLst>
+                                  <p:childTnLst>
+                                    <p:set>
+                                      <p:cBhvr>
+                                        <p:cTn id="54" dur="1" fill="hold">
+                                          <p:stCondLst>
+                                            <p:cond delay="0"/>
+                                          </p:stCondLst>
+                                        </p:cTn>
+                                        <p:tgtEl>
+                                          <p:spTgt spid="27"/>
+                                        </p:tgtEl>
+                                        <p:attrNameLst>
+                                          <p:attrName>style.visibility</p:attrName>
+                                        </p:attrNameLst>
+                                      </p:cBhvr>
+                                      <p:to>
+                                        <p:strVal val="visible"/>
+                                      </p:to>
+                                    </p:set>
+                                  </p:childTnLst>
+                                </p:cTn>
+                              </p:par>
+                              <p:par>
+                                <p:cTn id="55" presetID="1" presetClass="entr" presetSubtype="0" fill="hold" nodeType="withEffect">
+                                  <p:stCondLst>
+                                    <p:cond delay="0"/>
+                                  </p:stCondLst>
+                                  <p:childTnLst>
+                                    <p:set>
+                                      <p:cBhvr>
+                                        <p:cTn id="56" dur="1" fill="hold">
+                                          <p:stCondLst>
+                                            <p:cond delay="0"/>
+                                          </p:stCondLst>
+                                        </p:cTn>
+                                        <p:tgtEl>
+                                          <p:spTgt spid="28"/>
+                                        </p:tgtEl>
+                                        <p:attrNameLst>
+                                          <p:attrName>style.visibility</p:attrName>
+                                        </p:attrNameLst>
+                                      </p:cBhvr>
+                                      <p:to>
+                                        <p:strVal val="visible"/>
+                                      </p:to>
+                                    </p:set>
+                                  </p:childTnLst>
+                                </p:cTn>
+                              </p:par>
+                              <p:par>
+                                <p:cTn id="57" presetID="1" presetClass="entr" presetSubtype="0" fill="hold" grpId="0" nodeType="withEffect">
+                                  <p:stCondLst>
+                                    <p:cond delay="0"/>
+                                  </p:stCondLst>
+                                  <p:childTnLst>
+                                    <p:set>
+                                      <p:cBhvr>
+                                        <p:cTn id="58" dur="1" fill="hold">
+                                          <p:stCondLst>
+                                            <p:cond delay="0"/>
+                                          </p:stCondLst>
+                                        </p:cTn>
+                                        <p:tgtEl>
+                                          <p:spTgt spid="29"/>
+                                        </p:tgtEl>
+                                        <p:attrNameLst>
+                                          <p:attrName>style.visibility</p:attrName>
+                                        </p:attrNameLst>
+                                      </p:cBhvr>
+                                      <p:to>
+                                        <p:strVal val="visible"/>
+                                      </p:to>
+                                    </p:set>
+                                  </p:childTnLst>
+                                </p:cTn>
+                              </p:par>
+                            </p:childTnLst>
+                          </p:cTn>
+                        </p:par>
+                      </p:childTnLst>
+                    </p:cTn>
+                  </p:par>
+                </p:childTnLst>
+              </p:cTn>
+              <p:prevCondLst>
+                <p:cond evt="onPrev" delay="0">
+                  <p:tgtEl>
+                    <p:sldTgt/>
+                  </p:tgtEl>
+                </p:cond>
+              </p:prevCondLst>
+              <p:nextCondLst>
+                <p:cond evt="onNext" delay="0">
+                  <p:tgtEl>
+                    <p:sldTgt/>
+                  </p:tgtEl>
+                </p:cond>
+              </p:nextCondLst>
+            </p:seq>
+          </p:childTnLst>
+        </p:cTn>
+      </p:par>
+    </p:tnLst>
+    <p:bldLst>
+      <p:bldP spid="7" grpId="0" animBg="1"/>
+      <p:bldP spid="8" grpId="0" animBg="1"/>
+      <p:bldP spid="10" grpId="0" animBg="1"/>
+      <p:bldP spid="11" grpId="0" animBg="1"/>
+      <p:bldP spid="12" grpId="0" animBg="1"/>
+      <p:bldP spid="13" grpId="0" animBg="1"/>
+      <p:bldP spid="15" grpId="0" animBg="1"/>
+      <p:bldP spid="16" grpId="0" animBg="1"/>
+      <p:bldP spid="17" grpId="0" animBg="1"/>
+      <p:bldP spid="18" grpId="0" animBg="1"/>
+      <p:bldP spid="20" grpId="0" animBg="1"/>
+      <p:bldP spid="21" grpId="0" animBg="1"/>
+      <p:bldP spid="22" grpId="0" animBg="1"/>
+      <p:bldP spid="23" grpId="0" animBg="1"/>
+      <p:bldP spid="25" grpId="0" animBg="1"/>
+      <p:bldP spid="26" grpId="0" animBg="1"/>
+      <p:bldP spid="27" grpId="0" animBg="1"/>
+      <p:bldP spid="29" grpId="0" animBg="1"/>
+    </p:bldLst>
+  </p:timing>
 </p:sld>
 </file>
 
@@ -26900,7 +30344,7 @@
 </file>
 
 <file path=ppt/slides/slide28.xml><?xml version="1.0" encoding="utf-8"?>
-<p:sld xmlns:a="http://schemas.openxmlformats.org/drawingml/2006/main" xmlns:r="http://schemas.openxmlformats.org/officeDocument/2006/relationships" xmlns:p="http://schemas.openxmlformats.org/presentationml/2006/main">
+<p:sld xmlns:a="http://schemas.openxmlformats.org/drawingml/2006/main" xmlns:r="http://schemas.openxmlformats.org/officeDocument/2006/relationships" xmlns:p="http://schemas.openxmlformats.org/presentationml/2006/main" show="0">
   <p:cSld name="Slide 28">
     <p:bg>
       <p:bgPr>
@@ -29302,6 +32746,728 @@
   <p:clrMapOvr>
     <a:masterClrMapping/>
   </p:clrMapOvr>
+  <p:timing>
+    <p:tnLst>
+      <p:par>
+        <p:cTn id="1" dur="indefinite" restart="never" nodeType="tmRoot">
+          <p:childTnLst>
+            <p:seq concurrent="1" nextAc="seek">
+              <p:cTn id="2" dur="indefinite" nodeType="mainSeq">
+                <p:childTnLst>
+                  <p:par>
+                    <p:cTn id="3" fill="hold">
+                      <p:stCondLst>
+                        <p:cond delay="indefinite"/>
+                      </p:stCondLst>
+                      <p:childTnLst>
+                        <p:par>
+                          <p:cTn id="4" fill="hold">
+                            <p:stCondLst>
+                              <p:cond delay="0"/>
+                            </p:stCondLst>
+                            <p:childTnLst>
+                              <p:par>
+                                <p:cTn id="5" presetID="1" presetClass="entr" presetSubtype="0" fill="hold" grpId="0" nodeType="clickEffect">
+                                  <p:stCondLst>
+                                    <p:cond delay="0"/>
+                                  </p:stCondLst>
+                                  <p:childTnLst>
+                                    <p:set>
+                                      <p:cBhvr>
+                                        <p:cTn id="6" dur="1" fill="hold">
+                                          <p:stCondLst>
+                                            <p:cond delay="0"/>
+                                          </p:stCondLst>
+                                        </p:cTn>
+                                        <p:tgtEl>
+                                          <p:spTgt spid="7"/>
+                                        </p:tgtEl>
+                                        <p:attrNameLst>
+                                          <p:attrName>style.visibility</p:attrName>
+                                        </p:attrNameLst>
+                                      </p:cBhvr>
+                                      <p:to>
+                                        <p:strVal val="visible"/>
+                                      </p:to>
+                                    </p:set>
+                                  </p:childTnLst>
+                                </p:cTn>
+                              </p:par>
+                              <p:par>
+                                <p:cTn id="7" presetID="1" presetClass="entr" presetSubtype="0" fill="hold" grpId="0" nodeType="withEffect">
+                                  <p:stCondLst>
+                                    <p:cond delay="0"/>
+                                  </p:stCondLst>
+                                  <p:childTnLst>
+                                    <p:set>
+                                      <p:cBhvr>
+                                        <p:cTn id="8" dur="1" fill="hold">
+                                          <p:stCondLst>
+                                            <p:cond delay="0"/>
+                                          </p:stCondLst>
+                                        </p:cTn>
+                                        <p:tgtEl>
+                                          <p:spTgt spid="8"/>
+                                        </p:tgtEl>
+                                        <p:attrNameLst>
+                                          <p:attrName>style.visibility</p:attrName>
+                                        </p:attrNameLst>
+                                      </p:cBhvr>
+                                      <p:to>
+                                        <p:strVal val="visible"/>
+                                      </p:to>
+                                    </p:set>
+                                  </p:childTnLst>
+                                </p:cTn>
+                              </p:par>
+                              <p:par>
+                                <p:cTn id="9" presetID="1" presetClass="entr" presetSubtype="0" fill="hold" grpId="0" nodeType="withEffect">
+                                  <p:stCondLst>
+                                    <p:cond delay="0"/>
+                                  </p:stCondLst>
+                                  <p:childTnLst>
+                                    <p:set>
+                                      <p:cBhvr>
+                                        <p:cTn id="10" dur="1" fill="hold">
+                                          <p:stCondLst>
+                                            <p:cond delay="0"/>
+                                          </p:stCondLst>
+                                        </p:cTn>
+                                        <p:tgtEl>
+                                          <p:spTgt spid="9"/>
+                                        </p:tgtEl>
+                                        <p:attrNameLst>
+                                          <p:attrName>style.visibility</p:attrName>
+                                        </p:attrNameLst>
+                                      </p:cBhvr>
+                                      <p:to>
+                                        <p:strVal val="visible"/>
+                                      </p:to>
+                                    </p:set>
+                                  </p:childTnLst>
+                                </p:cTn>
+                              </p:par>
+                              <p:par>
+                                <p:cTn id="11" presetID="1" presetClass="entr" presetSubtype="0" fill="hold" grpId="0" nodeType="withEffect">
+                                  <p:stCondLst>
+                                    <p:cond delay="0"/>
+                                  </p:stCondLst>
+                                  <p:childTnLst>
+                                    <p:set>
+                                      <p:cBhvr>
+                                        <p:cTn id="12" dur="1" fill="hold">
+                                          <p:stCondLst>
+                                            <p:cond delay="0"/>
+                                          </p:stCondLst>
+                                        </p:cTn>
+                                        <p:tgtEl>
+                                          <p:spTgt spid="10"/>
+                                        </p:tgtEl>
+                                        <p:attrNameLst>
+                                          <p:attrName>style.visibility</p:attrName>
+                                        </p:attrNameLst>
+                                      </p:cBhvr>
+                                      <p:to>
+                                        <p:strVal val="visible"/>
+                                      </p:to>
+                                    </p:set>
+                                  </p:childTnLst>
+                                </p:cTn>
+                              </p:par>
+                              <p:par>
+                                <p:cTn id="13" presetID="1" presetClass="entr" presetSubtype="0" fill="hold" grpId="0" nodeType="withEffect">
+                                  <p:stCondLst>
+                                    <p:cond delay="0"/>
+                                  </p:stCondLst>
+                                  <p:childTnLst>
+                                    <p:set>
+                                      <p:cBhvr>
+                                        <p:cTn id="14" dur="1" fill="hold">
+                                          <p:stCondLst>
+                                            <p:cond delay="0"/>
+                                          </p:stCondLst>
+                                        </p:cTn>
+                                        <p:tgtEl>
+                                          <p:spTgt spid="11"/>
+                                        </p:tgtEl>
+                                        <p:attrNameLst>
+                                          <p:attrName>style.visibility</p:attrName>
+                                        </p:attrNameLst>
+                                      </p:cBhvr>
+                                      <p:to>
+                                        <p:strVal val="visible"/>
+                                      </p:to>
+                                    </p:set>
+                                  </p:childTnLst>
+                                </p:cTn>
+                              </p:par>
+                              <p:par>
+                                <p:cTn id="15" presetID="1" presetClass="entr" presetSubtype="0" fill="hold" grpId="0" nodeType="withEffect">
+                                  <p:stCondLst>
+                                    <p:cond delay="0"/>
+                                  </p:stCondLst>
+                                  <p:childTnLst>
+                                    <p:set>
+                                      <p:cBhvr>
+                                        <p:cTn id="16" dur="1" fill="hold">
+                                          <p:stCondLst>
+                                            <p:cond delay="0"/>
+                                          </p:stCondLst>
+                                        </p:cTn>
+                                        <p:tgtEl>
+                                          <p:spTgt spid="12"/>
+                                        </p:tgtEl>
+                                        <p:attrNameLst>
+                                          <p:attrName>style.visibility</p:attrName>
+                                        </p:attrNameLst>
+                                      </p:cBhvr>
+                                      <p:to>
+                                        <p:strVal val="visible"/>
+                                      </p:to>
+                                    </p:set>
+                                  </p:childTnLst>
+                                </p:cTn>
+                              </p:par>
+                              <p:par>
+                                <p:cTn id="17" presetID="1" presetClass="entr" presetSubtype="0" fill="hold" grpId="0" nodeType="withEffect">
+                                  <p:stCondLst>
+                                    <p:cond delay="0"/>
+                                  </p:stCondLst>
+                                  <p:childTnLst>
+                                    <p:set>
+                                      <p:cBhvr>
+                                        <p:cTn id="18" dur="1" fill="hold">
+                                          <p:stCondLst>
+                                            <p:cond delay="0"/>
+                                          </p:stCondLst>
+                                        </p:cTn>
+                                        <p:tgtEl>
+                                          <p:spTgt spid="13"/>
+                                        </p:tgtEl>
+                                        <p:attrNameLst>
+                                          <p:attrName>style.visibility</p:attrName>
+                                        </p:attrNameLst>
+                                      </p:cBhvr>
+                                      <p:to>
+                                        <p:strVal val="visible"/>
+                                      </p:to>
+                                    </p:set>
+                                  </p:childTnLst>
+                                </p:cTn>
+                              </p:par>
+                              <p:par>
+                                <p:cTn id="19" presetID="1" presetClass="entr" presetSubtype="0" fill="hold" grpId="0" nodeType="withEffect">
+                                  <p:stCondLst>
+                                    <p:cond delay="0"/>
+                                  </p:stCondLst>
+                                  <p:childTnLst>
+                                    <p:set>
+                                      <p:cBhvr>
+                                        <p:cTn id="20" dur="1" fill="hold">
+                                          <p:stCondLst>
+                                            <p:cond delay="0"/>
+                                          </p:stCondLst>
+                                        </p:cTn>
+                                        <p:tgtEl>
+                                          <p:spTgt spid="14"/>
+                                        </p:tgtEl>
+                                        <p:attrNameLst>
+                                          <p:attrName>style.visibility</p:attrName>
+                                        </p:attrNameLst>
+                                      </p:cBhvr>
+                                      <p:to>
+                                        <p:strVal val="visible"/>
+                                      </p:to>
+                                    </p:set>
+                                  </p:childTnLst>
+                                </p:cTn>
+                              </p:par>
+                              <p:par>
+                                <p:cTn id="21" presetID="1" presetClass="entr" presetSubtype="0" fill="hold" grpId="0" nodeType="withEffect">
+                                  <p:stCondLst>
+                                    <p:cond delay="0"/>
+                                  </p:stCondLst>
+                                  <p:childTnLst>
+                                    <p:set>
+                                      <p:cBhvr>
+                                        <p:cTn id="22" dur="1" fill="hold">
+                                          <p:stCondLst>
+                                            <p:cond delay="0"/>
+                                          </p:stCondLst>
+                                        </p:cTn>
+                                        <p:tgtEl>
+                                          <p:spTgt spid="15"/>
+                                        </p:tgtEl>
+                                        <p:attrNameLst>
+                                          <p:attrName>style.visibility</p:attrName>
+                                        </p:attrNameLst>
+                                      </p:cBhvr>
+                                      <p:to>
+                                        <p:strVal val="visible"/>
+                                      </p:to>
+                                    </p:set>
+                                  </p:childTnLst>
+                                </p:cTn>
+                              </p:par>
+                              <p:par>
+                                <p:cTn id="23" presetID="1" presetClass="entr" presetSubtype="0" fill="hold" grpId="0" nodeType="withEffect">
+                                  <p:stCondLst>
+                                    <p:cond delay="0"/>
+                                  </p:stCondLst>
+                                  <p:childTnLst>
+                                    <p:set>
+                                      <p:cBhvr>
+                                        <p:cTn id="24" dur="1" fill="hold">
+                                          <p:stCondLst>
+                                            <p:cond delay="0"/>
+                                          </p:stCondLst>
+                                        </p:cTn>
+                                        <p:tgtEl>
+                                          <p:spTgt spid="16"/>
+                                        </p:tgtEl>
+                                        <p:attrNameLst>
+                                          <p:attrName>style.visibility</p:attrName>
+                                        </p:attrNameLst>
+                                      </p:cBhvr>
+                                      <p:to>
+                                        <p:strVal val="visible"/>
+                                      </p:to>
+                                    </p:set>
+                                  </p:childTnLst>
+                                </p:cTn>
+                              </p:par>
+                              <p:par>
+                                <p:cTn id="25" presetID="1" presetClass="entr" presetSubtype="0" fill="hold" grpId="0" nodeType="withEffect">
+                                  <p:stCondLst>
+                                    <p:cond delay="0"/>
+                                  </p:stCondLst>
+                                  <p:childTnLst>
+                                    <p:set>
+                                      <p:cBhvr>
+                                        <p:cTn id="26" dur="1" fill="hold">
+                                          <p:stCondLst>
+                                            <p:cond delay="0"/>
+                                          </p:stCondLst>
+                                        </p:cTn>
+                                        <p:tgtEl>
+                                          <p:spTgt spid="17"/>
+                                        </p:tgtEl>
+                                        <p:attrNameLst>
+                                          <p:attrName>style.visibility</p:attrName>
+                                        </p:attrNameLst>
+                                      </p:cBhvr>
+                                      <p:to>
+                                        <p:strVal val="visible"/>
+                                      </p:to>
+                                    </p:set>
+                                  </p:childTnLst>
+                                </p:cTn>
+                              </p:par>
+                              <p:par>
+                                <p:cTn id="27" presetID="1" presetClass="entr" presetSubtype="0" fill="hold" grpId="0" nodeType="withEffect">
+                                  <p:stCondLst>
+                                    <p:cond delay="0"/>
+                                  </p:stCondLst>
+                                  <p:childTnLst>
+                                    <p:set>
+                                      <p:cBhvr>
+                                        <p:cTn id="28" dur="1" fill="hold">
+                                          <p:stCondLst>
+                                            <p:cond delay="0"/>
+                                          </p:stCondLst>
+                                        </p:cTn>
+                                        <p:tgtEl>
+                                          <p:spTgt spid="18"/>
+                                        </p:tgtEl>
+                                        <p:attrNameLst>
+                                          <p:attrName>style.visibility</p:attrName>
+                                        </p:attrNameLst>
+                                      </p:cBhvr>
+                                      <p:to>
+                                        <p:strVal val="visible"/>
+                                      </p:to>
+                                    </p:set>
+                                  </p:childTnLst>
+                                </p:cTn>
+                              </p:par>
+                              <p:par>
+                                <p:cTn id="29" presetID="1" presetClass="entr" presetSubtype="0" fill="hold" grpId="0" nodeType="withEffect">
+                                  <p:stCondLst>
+                                    <p:cond delay="0"/>
+                                  </p:stCondLst>
+                                  <p:childTnLst>
+                                    <p:set>
+                                      <p:cBhvr>
+                                        <p:cTn id="30" dur="1" fill="hold">
+                                          <p:stCondLst>
+                                            <p:cond delay="0"/>
+                                          </p:stCondLst>
+                                        </p:cTn>
+                                        <p:tgtEl>
+                                          <p:spTgt spid="19"/>
+                                        </p:tgtEl>
+                                        <p:attrNameLst>
+                                          <p:attrName>style.visibility</p:attrName>
+                                        </p:attrNameLst>
+                                      </p:cBhvr>
+                                      <p:to>
+                                        <p:strVal val="visible"/>
+                                      </p:to>
+                                    </p:set>
+                                  </p:childTnLst>
+                                </p:cTn>
+                              </p:par>
+                              <p:par>
+                                <p:cTn id="31" presetID="1" presetClass="entr" presetSubtype="0" fill="hold" grpId="0" nodeType="withEffect">
+                                  <p:stCondLst>
+                                    <p:cond delay="0"/>
+                                  </p:stCondLst>
+                                  <p:childTnLst>
+                                    <p:set>
+                                      <p:cBhvr>
+                                        <p:cTn id="32" dur="1" fill="hold">
+                                          <p:stCondLst>
+                                            <p:cond delay="0"/>
+                                          </p:stCondLst>
+                                        </p:cTn>
+                                        <p:tgtEl>
+                                          <p:spTgt spid="20"/>
+                                        </p:tgtEl>
+                                        <p:attrNameLst>
+                                          <p:attrName>style.visibility</p:attrName>
+                                        </p:attrNameLst>
+                                      </p:cBhvr>
+                                      <p:to>
+                                        <p:strVal val="visible"/>
+                                      </p:to>
+                                    </p:set>
+                                  </p:childTnLst>
+                                </p:cTn>
+                              </p:par>
+                              <p:par>
+                                <p:cTn id="33" presetID="1" presetClass="entr" presetSubtype="0" fill="hold" grpId="0" nodeType="withEffect">
+                                  <p:stCondLst>
+                                    <p:cond delay="0"/>
+                                  </p:stCondLst>
+                                  <p:childTnLst>
+                                    <p:set>
+                                      <p:cBhvr>
+                                        <p:cTn id="34" dur="1" fill="hold">
+                                          <p:stCondLst>
+                                            <p:cond delay="0"/>
+                                          </p:stCondLst>
+                                        </p:cTn>
+                                        <p:tgtEl>
+                                          <p:spTgt spid="21"/>
+                                        </p:tgtEl>
+                                        <p:attrNameLst>
+                                          <p:attrName>style.visibility</p:attrName>
+                                        </p:attrNameLst>
+                                      </p:cBhvr>
+                                      <p:to>
+                                        <p:strVal val="visible"/>
+                                      </p:to>
+                                    </p:set>
+                                  </p:childTnLst>
+                                </p:cTn>
+                              </p:par>
+                              <p:par>
+                                <p:cTn id="35" presetID="1" presetClass="entr" presetSubtype="0" fill="hold" grpId="0" nodeType="withEffect">
+                                  <p:stCondLst>
+                                    <p:cond delay="0"/>
+                                  </p:stCondLst>
+                                  <p:childTnLst>
+                                    <p:set>
+                                      <p:cBhvr>
+                                        <p:cTn id="36" dur="1" fill="hold">
+                                          <p:stCondLst>
+                                            <p:cond delay="0"/>
+                                          </p:stCondLst>
+                                        </p:cTn>
+                                        <p:tgtEl>
+                                          <p:spTgt spid="22"/>
+                                        </p:tgtEl>
+                                        <p:attrNameLst>
+                                          <p:attrName>style.visibility</p:attrName>
+                                        </p:attrNameLst>
+                                      </p:cBhvr>
+                                      <p:to>
+                                        <p:strVal val="visible"/>
+                                      </p:to>
+                                    </p:set>
+                                  </p:childTnLst>
+                                </p:cTn>
+                              </p:par>
+                              <p:par>
+                                <p:cTn id="37" presetID="1" presetClass="entr" presetSubtype="0" fill="hold" grpId="0" nodeType="withEffect">
+                                  <p:stCondLst>
+                                    <p:cond delay="0"/>
+                                  </p:stCondLst>
+                                  <p:childTnLst>
+                                    <p:set>
+                                      <p:cBhvr>
+                                        <p:cTn id="38" dur="1" fill="hold">
+                                          <p:stCondLst>
+                                            <p:cond delay="0"/>
+                                          </p:stCondLst>
+                                        </p:cTn>
+                                        <p:tgtEl>
+                                          <p:spTgt spid="23"/>
+                                        </p:tgtEl>
+                                        <p:attrNameLst>
+                                          <p:attrName>style.visibility</p:attrName>
+                                        </p:attrNameLst>
+                                      </p:cBhvr>
+                                      <p:to>
+                                        <p:strVal val="visible"/>
+                                      </p:to>
+                                    </p:set>
+                                  </p:childTnLst>
+                                </p:cTn>
+                              </p:par>
+                              <p:par>
+                                <p:cTn id="39" presetID="1" presetClass="entr" presetSubtype="0" fill="hold" grpId="0" nodeType="withEffect">
+                                  <p:stCondLst>
+                                    <p:cond delay="0"/>
+                                  </p:stCondLst>
+                                  <p:childTnLst>
+                                    <p:set>
+                                      <p:cBhvr>
+                                        <p:cTn id="40" dur="1" fill="hold">
+                                          <p:stCondLst>
+                                            <p:cond delay="0"/>
+                                          </p:stCondLst>
+                                        </p:cTn>
+                                        <p:tgtEl>
+                                          <p:spTgt spid="24"/>
+                                        </p:tgtEl>
+                                        <p:attrNameLst>
+                                          <p:attrName>style.visibility</p:attrName>
+                                        </p:attrNameLst>
+                                      </p:cBhvr>
+                                      <p:to>
+                                        <p:strVal val="visible"/>
+                                      </p:to>
+                                    </p:set>
+                                  </p:childTnLst>
+                                </p:cTn>
+                              </p:par>
+                              <p:par>
+                                <p:cTn id="41" presetID="1" presetClass="entr" presetSubtype="0" fill="hold" grpId="0" nodeType="withEffect">
+                                  <p:stCondLst>
+                                    <p:cond delay="0"/>
+                                  </p:stCondLst>
+                                  <p:childTnLst>
+                                    <p:set>
+                                      <p:cBhvr>
+                                        <p:cTn id="42" dur="1" fill="hold">
+                                          <p:stCondLst>
+                                            <p:cond delay="0"/>
+                                          </p:stCondLst>
+                                        </p:cTn>
+                                        <p:tgtEl>
+                                          <p:spTgt spid="25"/>
+                                        </p:tgtEl>
+                                        <p:attrNameLst>
+                                          <p:attrName>style.visibility</p:attrName>
+                                        </p:attrNameLst>
+                                      </p:cBhvr>
+                                      <p:to>
+                                        <p:strVal val="visible"/>
+                                      </p:to>
+                                    </p:set>
+                                  </p:childTnLst>
+                                </p:cTn>
+                              </p:par>
+                              <p:par>
+                                <p:cTn id="43" presetID="1" presetClass="entr" presetSubtype="0" fill="hold" grpId="0" nodeType="withEffect">
+                                  <p:stCondLst>
+                                    <p:cond delay="0"/>
+                                  </p:stCondLst>
+                                  <p:childTnLst>
+                                    <p:set>
+                                      <p:cBhvr>
+                                        <p:cTn id="44" dur="1" fill="hold">
+                                          <p:stCondLst>
+                                            <p:cond delay="0"/>
+                                          </p:stCondLst>
+                                        </p:cTn>
+                                        <p:tgtEl>
+                                          <p:spTgt spid="26"/>
+                                        </p:tgtEl>
+                                        <p:attrNameLst>
+                                          <p:attrName>style.visibility</p:attrName>
+                                        </p:attrNameLst>
+                                      </p:cBhvr>
+                                      <p:to>
+                                        <p:strVal val="visible"/>
+                                      </p:to>
+                                    </p:set>
+                                  </p:childTnLst>
+                                </p:cTn>
+                              </p:par>
+                              <p:par>
+                                <p:cTn id="45" presetID="1" presetClass="entr" presetSubtype="0" fill="hold" grpId="0" nodeType="withEffect">
+                                  <p:stCondLst>
+                                    <p:cond delay="0"/>
+                                  </p:stCondLst>
+                                  <p:childTnLst>
+                                    <p:set>
+                                      <p:cBhvr>
+                                        <p:cTn id="46" dur="1" fill="hold">
+                                          <p:stCondLst>
+                                            <p:cond delay="0"/>
+                                          </p:stCondLst>
+                                        </p:cTn>
+                                        <p:tgtEl>
+                                          <p:spTgt spid="27"/>
+                                        </p:tgtEl>
+                                        <p:attrNameLst>
+                                          <p:attrName>style.visibility</p:attrName>
+                                        </p:attrNameLst>
+                                      </p:cBhvr>
+                                      <p:to>
+                                        <p:strVal val="visible"/>
+                                      </p:to>
+                                    </p:set>
+                                  </p:childTnLst>
+                                </p:cTn>
+                              </p:par>
+                              <p:par>
+                                <p:cTn id="47" presetID="1" presetClass="entr" presetSubtype="0" fill="hold" grpId="0" nodeType="withEffect">
+                                  <p:stCondLst>
+                                    <p:cond delay="0"/>
+                                  </p:stCondLst>
+                                  <p:childTnLst>
+                                    <p:set>
+                                      <p:cBhvr>
+                                        <p:cTn id="48" dur="1" fill="hold">
+                                          <p:stCondLst>
+                                            <p:cond delay="0"/>
+                                          </p:stCondLst>
+                                        </p:cTn>
+                                        <p:tgtEl>
+                                          <p:spTgt spid="28"/>
+                                        </p:tgtEl>
+                                        <p:attrNameLst>
+                                          <p:attrName>style.visibility</p:attrName>
+                                        </p:attrNameLst>
+                                      </p:cBhvr>
+                                      <p:to>
+                                        <p:strVal val="visible"/>
+                                      </p:to>
+                                    </p:set>
+                                  </p:childTnLst>
+                                </p:cTn>
+                              </p:par>
+                              <p:par>
+                                <p:cTn id="49" presetID="1" presetClass="entr" presetSubtype="0" fill="hold" grpId="0" nodeType="withEffect">
+                                  <p:stCondLst>
+                                    <p:cond delay="0"/>
+                                  </p:stCondLst>
+                                  <p:childTnLst>
+                                    <p:set>
+                                      <p:cBhvr>
+                                        <p:cTn id="50" dur="1" fill="hold">
+                                          <p:stCondLst>
+                                            <p:cond delay="0"/>
+                                          </p:stCondLst>
+                                        </p:cTn>
+                                        <p:tgtEl>
+                                          <p:spTgt spid="29"/>
+                                        </p:tgtEl>
+                                        <p:attrNameLst>
+                                          <p:attrName>style.visibility</p:attrName>
+                                        </p:attrNameLst>
+                                      </p:cBhvr>
+                                      <p:to>
+                                        <p:strVal val="visible"/>
+                                      </p:to>
+                                    </p:set>
+                                  </p:childTnLst>
+                                </p:cTn>
+                              </p:par>
+                              <p:par>
+                                <p:cTn id="51" presetID="1" presetClass="entr" presetSubtype="0" fill="hold" grpId="0" nodeType="withEffect">
+                                  <p:stCondLst>
+                                    <p:cond delay="0"/>
+                                  </p:stCondLst>
+                                  <p:childTnLst>
+                                    <p:set>
+                                      <p:cBhvr>
+                                        <p:cTn id="52" dur="1" fill="hold">
+                                          <p:stCondLst>
+                                            <p:cond delay="0"/>
+                                          </p:stCondLst>
+                                        </p:cTn>
+                                        <p:tgtEl>
+                                          <p:spTgt spid="30"/>
+                                        </p:tgtEl>
+                                        <p:attrNameLst>
+                                          <p:attrName>style.visibility</p:attrName>
+                                        </p:attrNameLst>
+                                      </p:cBhvr>
+                                      <p:to>
+                                        <p:strVal val="visible"/>
+                                      </p:to>
+                                    </p:set>
+                                  </p:childTnLst>
+                                </p:cTn>
+                              </p:par>
+                            </p:childTnLst>
+                          </p:cTn>
+                        </p:par>
+                      </p:childTnLst>
+                    </p:cTn>
+                  </p:par>
+                </p:childTnLst>
+              </p:cTn>
+              <p:prevCondLst>
+                <p:cond evt="onPrev" delay="0">
+                  <p:tgtEl>
+                    <p:sldTgt/>
+                  </p:tgtEl>
+                </p:cond>
+              </p:prevCondLst>
+              <p:nextCondLst>
+                <p:cond evt="onNext" delay="0">
+                  <p:tgtEl>
+                    <p:sldTgt/>
+                  </p:tgtEl>
+                </p:cond>
+              </p:nextCondLst>
+            </p:seq>
+          </p:childTnLst>
+        </p:cTn>
+      </p:par>
+    </p:tnLst>
+    <p:bldLst>
+      <p:bldP spid="7" grpId="0" animBg="1"/>
+      <p:bldP spid="8" grpId="0" animBg="1"/>
+      <p:bldP spid="9" grpId="0" animBg="1"/>
+      <p:bldP spid="10" grpId="0" animBg="1"/>
+      <p:bldP spid="11" grpId="0" animBg="1"/>
+      <p:bldP spid="12" grpId="0" animBg="1"/>
+      <p:bldP spid="13" grpId="0" animBg="1"/>
+      <p:bldP spid="14" grpId="0" animBg="1"/>
+      <p:bldP spid="15" grpId="0" animBg="1"/>
+      <p:bldP spid="16" grpId="0" animBg="1"/>
+      <p:bldP spid="17" grpId="0" animBg="1"/>
+      <p:bldP spid="18" grpId="0" animBg="1"/>
+      <p:bldP spid="19" grpId="0" animBg="1"/>
+      <p:bldP spid="20" grpId="0" animBg="1"/>
+      <p:bldP spid="21" grpId="0" animBg="1"/>
+      <p:bldP spid="22" grpId="0" animBg="1"/>
+      <p:bldP spid="23" grpId="0" animBg="1"/>
+      <p:bldP spid="24" grpId="0" animBg="1"/>
+      <p:bldP spid="25" grpId="0" animBg="1"/>
+      <p:bldP spid="26" grpId="0" animBg="1"/>
+      <p:bldP spid="27" grpId="0" animBg="1"/>
+      <p:bldP spid="28" grpId="0" animBg="1"/>
+      <p:bldP spid="29" grpId="0" animBg="1"/>
+      <p:bldP spid="30" grpId="0" animBg="1"/>
+    </p:bldLst>
+  </p:timing>
 </p:sld>
 </file>
 

</xml_diff>